<commit_message>
Status GAia na jednym slajdzie: jedna tabela z Excela
Co-Authored-By: Claude Opus 5.5 <noreply@anthropic.com>
Claude-Session: https://claude.ai/code/session_01HLzk51tscwKpTxY48VqnmK
</commit_message>
<xml_diff>
--- a/GAia_Status_dla_Prezesa.pptx
+++ b/GAia_Status_dla_Prezesa.pptx
@@ -6,12 +6,9 @@
   </p:sldMasterIdLst>
   <p:sldIdLst>
     <p:sldId id="256" r:id="rId2"/>
-    <p:sldId id="257" r:id="rId3"/>
-    <p:sldId id="258" r:id="rId4"/>
-    <p:sldId id="259" r:id="rId5"/>
   </p:sldIdLst>
   <p:notesMasterIdLst>
-    <p:notesMasterId r:id="rId6"/>
+    <p:notesMasterId r:id="rId3"/>
   </p:notesMasterIdLst>
   <p:sldSz cx="9144000" cy="5143500"/>
   <p:notesSz cx="5143500" cy="9144000"/>
@@ -110,24 +107,9 @@
   <p:extLst>
     <p:ext uri="{521415D9-36F7-43E2-AB2F-B90AF26B5E84}">
       <p14:sectionLst xmlns:p14="http://schemas.microsoft.com/office/powerpoint/2010/main">
-        <p14:section name="Partnerzy instytucjonalni" id="{bae46d95-0a17-2147-af34-47db7f62b812}">
+        <p14:section name="Status" id="{74199ade-f795-37de-8fcf-ad65f2b27bfe}">
           <p14:sldIdLst>
             <p14:sldId id="256"/>
-          </p14:sldIdLst>
-        </p14:section>
-        <p14:section name="Partnerzy komercyjni" id="{2102109b-0f58-0bb0-fee9-97a1810d9501}">
-          <p14:sldIdLst>
-            <p14:sldId id="257"/>
-          </p14:sldIdLst>
-        </p14:section>
-        <p14:section name="Technologia i strategia" id="{cd9caf34-bc0d-853e-cd9f-3dddc4c7b136}">
-          <p14:sldIdLst>
-            <p14:sldId id="258"/>
-          </p14:sldIdLst>
-        </p14:section>
-        <p14:section name="Do dyskusji" id="{64f119d8-c52e-149e-f182-4084a34101b5}">
-          <p14:sldIdLst>
-            <p14:sldId id="259"/>
           </p14:sldIdLst>
         </p14:section>
       </p14:sectionLst>
@@ -576,270 +558,6 @@
 </p:notes>
 </file>
 
-<file path=ppt/notesSlides/notesSlide2.xml><?xml version="1.0" encoding="utf-8"?>
-<p:notes xmlns:a="http://schemas.openxmlformats.org/drawingml/2006/main" xmlns:r="http://schemas.openxmlformats.org/officeDocument/2006/relationships" xmlns:p="http://schemas.openxmlformats.org/presentationml/2006/main">
-  <p:cSld>
-    <p:spTree>
-      <p:nvGrpSpPr>
-        <p:cNvPr id="1" name=""/>
-        <p:cNvGrpSpPr/>
-        <p:nvPr/>
-      </p:nvGrpSpPr>
-      <p:grpSpPr>
-        <a:xfrm>
-          <a:off x="0" y="0"/>
-          <a:ext cx="0" cy="0"/>
-          <a:chOff x="0" y="0"/>
-          <a:chExt cx="0" cy="0"/>
-        </a:xfrm>
-      </p:grpSpPr>
-      <p:sp>
-        <p:nvSpPr>
-          <p:cNvPr id="2" name="Slide Image Placeholder 1"/>
-          <p:cNvSpPr>
-            <a:spLocks noGrp="1" noRot="1" noChangeAspect="1"/>
-          </p:cNvSpPr>
-          <p:nvPr>
-            <p:ph type="sldImg"/>
-          </p:nvPr>
-        </p:nvSpPr>
-        <p:spPr/>
-      </p:sp>
-      <p:sp>
-        <p:nvSpPr>
-          <p:cNvPr id="3" name="Notes Placeholder 2"/>
-          <p:cNvSpPr>
-            <a:spLocks noGrp="1"/>
-          </p:cNvSpPr>
-          <p:nvPr>
-            <p:ph type="body" idx="1"/>
-          </p:nvPr>
-        </p:nvSpPr>
-        <p:spPr/>
-        <p:txBody>
-          <a:bodyPr/>
-          <a:lstStyle/>
-          <a:p>
-            <a:r>
-              <a:rPr lang="en-US" dirty="0"/>
-              <a:t/>
-            </a:r>
-            <a:endParaRPr lang="en-US" dirty="0"/>
-          </a:p>
-        </p:txBody>
-      </p:sp>
-      <p:sp>
-        <p:nvSpPr>
-          <p:cNvPr id="4" name="Slide Number Placeholder 3"/>
-          <p:cNvSpPr>
-            <a:spLocks noGrp="1"/>
-          </p:cNvSpPr>
-          <p:nvPr>
-            <p:ph type="sldNum" sz="quarter" idx="10"/>
-          </p:nvPr>
-        </p:nvSpPr>
-        <p:spPr/>
-        <p:txBody>
-          <a:bodyPr/>
-          <a:lstStyle/>
-          <a:p>
-            <a:fld id="{F7021451-1387-4CA6-816F-3879F97B5CBC}" type="slidenum">
-              <a:rPr lang="en-US"/>
-              <a:t>2</a:t>
-            </a:fld>
-            <a:endParaRPr lang="en-US"/>
-          </a:p>
-        </p:txBody>
-      </p:sp>
-    </p:spTree>
-    <p:extLst>
-      <p:ext uri="{BB962C8B-B14F-4D97-AF65-F5344CB8AC3E}">
-        <p14:creationId xmlns:p14="http://schemas.microsoft.com/office/powerpoint/2010/main" val="1024086991"/>
-      </p:ext>
-    </p:extLst>
-  </p:cSld>
-  <p:clrMapOvr>
-    <a:masterClrMapping/>
-  </p:clrMapOvr>
-</p:notes>
-</file>
-
-<file path=ppt/notesSlides/notesSlide3.xml><?xml version="1.0" encoding="utf-8"?>
-<p:notes xmlns:a="http://schemas.openxmlformats.org/drawingml/2006/main" xmlns:r="http://schemas.openxmlformats.org/officeDocument/2006/relationships" xmlns:p="http://schemas.openxmlformats.org/presentationml/2006/main">
-  <p:cSld>
-    <p:spTree>
-      <p:nvGrpSpPr>
-        <p:cNvPr id="1" name=""/>
-        <p:cNvGrpSpPr/>
-        <p:nvPr/>
-      </p:nvGrpSpPr>
-      <p:grpSpPr>
-        <a:xfrm>
-          <a:off x="0" y="0"/>
-          <a:ext cx="0" cy="0"/>
-          <a:chOff x="0" y="0"/>
-          <a:chExt cx="0" cy="0"/>
-        </a:xfrm>
-      </p:grpSpPr>
-      <p:sp>
-        <p:nvSpPr>
-          <p:cNvPr id="2" name="Slide Image Placeholder 1"/>
-          <p:cNvSpPr>
-            <a:spLocks noGrp="1" noRot="1" noChangeAspect="1"/>
-          </p:cNvSpPr>
-          <p:nvPr>
-            <p:ph type="sldImg"/>
-          </p:nvPr>
-        </p:nvSpPr>
-        <p:spPr/>
-      </p:sp>
-      <p:sp>
-        <p:nvSpPr>
-          <p:cNvPr id="3" name="Notes Placeholder 2"/>
-          <p:cNvSpPr>
-            <a:spLocks noGrp="1"/>
-          </p:cNvSpPr>
-          <p:nvPr>
-            <p:ph type="body" idx="1"/>
-          </p:nvPr>
-        </p:nvSpPr>
-        <p:spPr/>
-        <p:txBody>
-          <a:bodyPr/>
-          <a:lstStyle/>
-          <a:p>
-            <a:r>
-              <a:rPr lang="en-US" dirty="0"/>
-              <a:t/>
-            </a:r>
-            <a:endParaRPr lang="en-US" dirty="0"/>
-          </a:p>
-        </p:txBody>
-      </p:sp>
-      <p:sp>
-        <p:nvSpPr>
-          <p:cNvPr id="4" name="Slide Number Placeholder 3"/>
-          <p:cNvSpPr>
-            <a:spLocks noGrp="1"/>
-          </p:cNvSpPr>
-          <p:nvPr>
-            <p:ph type="sldNum" sz="quarter" idx="10"/>
-          </p:nvPr>
-        </p:nvSpPr>
-        <p:spPr/>
-        <p:txBody>
-          <a:bodyPr/>
-          <a:lstStyle/>
-          <a:p>
-            <a:fld id="{F7021451-1387-4CA6-816F-3879F97B5CBC}" type="slidenum">
-              <a:rPr lang="en-US"/>
-              <a:t>3</a:t>
-            </a:fld>
-            <a:endParaRPr lang="en-US"/>
-          </a:p>
-        </p:txBody>
-      </p:sp>
-    </p:spTree>
-    <p:extLst>
-      <p:ext uri="{BB962C8B-B14F-4D97-AF65-F5344CB8AC3E}">
-        <p14:creationId xmlns:p14="http://schemas.microsoft.com/office/powerpoint/2010/main" val="1024086991"/>
-      </p:ext>
-    </p:extLst>
-  </p:cSld>
-  <p:clrMapOvr>
-    <a:masterClrMapping/>
-  </p:clrMapOvr>
-</p:notes>
-</file>
-
-<file path=ppt/notesSlides/notesSlide4.xml><?xml version="1.0" encoding="utf-8"?>
-<p:notes xmlns:a="http://schemas.openxmlformats.org/drawingml/2006/main" xmlns:r="http://schemas.openxmlformats.org/officeDocument/2006/relationships" xmlns:p="http://schemas.openxmlformats.org/presentationml/2006/main">
-  <p:cSld>
-    <p:spTree>
-      <p:nvGrpSpPr>
-        <p:cNvPr id="1" name=""/>
-        <p:cNvGrpSpPr/>
-        <p:nvPr/>
-      </p:nvGrpSpPr>
-      <p:grpSpPr>
-        <a:xfrm>
-          <a:off x="0" y="0"/>
-          <a:ext cx="0" cy="0"/>
-          <a:chOff x="0" y="0"/>
-          <a:chExt cx="0" cy="0"/>
-        </a:xfrm>
-      </p:grpSpPr>
-      <p:sp>
-        <p:nvSpPr>
-          <p:cNvPr id="2" name="Slide Image Placeholder 1"/>
-          <p:cNvSpPr>
-            <a:spLocks noGrp="1" noRot="1" noChangeAspect="1"/>
-          </p:cNvSpPr>
-          <p:nvPr>
-            <p:ph type="sldImg"/>
-          </p:nvPr>
-        </p:nvSpPr>
-        <p:spPr/>
-      </p:sp>
-      <p:sp>
-        <p:nvSpPr>
-          <p:cNvPr id="3" name="Notes Placeholder 2"/>
-          <p:cNvSpPr>
-            <a:spLocks noGrp="1"/>
-          </p:cNvSpPr>
-          <p:nvPr>
-            <p:ph type="body" idx="1"/>
-          </p:nvPr>
-        </p:nvSpPr>
-        <p:spPr/>
-        <p:txBody>
-          <a:bodyPr/>
-          <a:lstStyle/>
-          <a:p>
-            <a:r>
-              <a:rPr lang="en-US" dirty="0"/>
-              <a:t/>
-            </a:r>
-            <a:endParaRPr lang="en-US" dirty="0"/>
-          </a:p>
-        </p:txBody>
-      </p:sp>
-      <p:sp>
-        <p:nvSpPr>
-          <p:cNvPr id="4" name="Slide Number Placeholder 3"/>
-          <p:cNvSpPr>
-            <a:spLocks noGrp="1"/>
-          </p:cNvSpPr>
-          <p:nvPr>
-            <p:ph type="sldNum" sz="quarter" idx="10"/>
-          </p:nvPr>
-        </p:nvSpPr>
-        <p:spPr/>
-        <p:txBody>
-          <a:bodyPr/>
-          <a:lstStyle/>
-          <a:p>
-            <a:fld id="{F7021451-1387-4CA6-816F-3879F97B5CBC}" type="slidenum">
-              <a:rPr lang="en-US"/>
-              <a:t>4</a:t>
-            </a:fld>
-            <a:endParaRPr lang="en-US"/>
-          </a:p>
-        </p:txBody>
-      </p:sp>
-    </p:spTree>
-    <p:extLst>
-      <p:ext uri="{BB962C8B-B14F-4D97-AF65-F5344CB8AC3E}">
-        <p14:creationId xmlns:p14="http://schemas.microsoft.com/office/powerpoint/2010/main" val="1024086991"/>
-      </p:ext>
-    </p:extLst>
-  </p:cSld>
-  <p:clrMapOvr>
-    <a:masterClrMapping/>
-  </p:clrMapOvr>
-</p:notes>
-</file>
-
 <file path=ppt/slideLayouts/slideLayout1.xml><?xml version="1.0" encoding="utf-8"?>
 <p:sldLayout xmlns:a="http://schemas.openxmlformats.org/drawingml/2006/main" xmlns:r="http://schemas.openxmlformats.org/officeDocument/2006/relationships" xmlns:p="http://schemas.openxmlformats.org/presentationml/2006/main" preserve="1">
   <p:cSld name="DEFAULT">
@@ -872,7 +590,7 @@
 
 <file path=ppt/slideLayouts/slideLayout2.xml><?xml version="1.0" encoding="utf-8"?>
 <p:sldLayout xmlns:a="http://schemas.openxmlformats.org/drawingml/2006/main" xmlns:r="http://schemas.openxmlformats.org/officeDocument/2006/relationships" xmlns:p="http://schemas.openxmlformats.org/presentationml/2006/main" preserve="1">
-  <p:cSld name="Sekcja">
+  <p:cSld name="Tabela">
     <p:bg>
       <p:bgPr>
         <a:solidFill>
@@ -898,50 +616,14 @@
         <p:nvSpPr>
           <p:cNvPr id="2" name="Text 0"/>
           <p:cNvSpPr/>
-          <p:nvPr/>
-        </p:nvSpPr>
-        <p:spPr>
-          <a:xfrm>
-            <a:off x="457200" y="292608"/>
-            <a:ext cx="8229600" cy="182880"/>
-          </a:xfrm>
-          <a:prstGeom prst="rect">
-            <a:avLst/>
-          </a:prstGeom>
-          <a:noFill/>
-          <a:ln/>
-        </p:spPr>
-        <p:txBody>
-          <a:bodyPr wrap="square" lIns="0" tIns="0" rIns="0" bIns="0" rtlCol="0" anchor="ctr"/>
-          <a:lstStyle/>
-          <a:p>
-            <a:pPr indent="0" marL="0">
-              <a:buNone/>
-            </a:pPr>
-            <a:r>
-              <a:rPr lang="en-US" sz="900" b="1" spc="150" kern="0" dirty="0">
-                <a:solidFill>
-                  <a:schemeClr val="accent3"/>
-                </a:solidFill>
-              </a:rPr>
-              <a:t>STATUS PROJEKTU GAia  ·  STAN NA 5.10.2026</a:t>
-            </a:r>
-            <a:endParaRPr lang="en-US" sz="900" dirty="0"/>
-          </a:p>
-        </p:txBody>
-      </p:sp>
-      <p:sp>
-        <p:nvSpPr>
-          <p:cNvPr id="3" name="Text 1"/>
-          <p:cNvSpPr/>
           <p:nvPr>
-            <p:ph idx="101" type="title" hasCustomPrompt="1"/>
+            <p:ph idx="100" type="title" hasCustomPrompt="1"/>
           </p:nvPr>
         </p:nvSpPr>
         <p:spPr>
           <a:xfrm>
-            <a:off x="457200" y="502920"/>
-            <a:ext cx="8229600" cy="457200"/>
+            <a:off x="365760" y="201168"/>
+            <a:ext cx="6035040" cy="384048"/>
           </a:xfrm>
           <a:prstGeom prst="rect">
             <a:avLst/>
@@ -954,7 +636,7 @@
           <a:lstStyle>
             <a:lvl1pPr algn="l" indent="0" marL="0">
               <a:buNone/>
-              <a:defRPr lang="en-US" sz="2600" b="1" dirty="0">
+              <a:defRPr lang="en-US" sz="2000" b="1" dirty="0">
                 <a:solidFill>
                   <a:schemeClr val="accent1"/>
                 </a:solidFill>
@@ -965,20 +647,20 @@
             <a:pPr algn="l" indent="0" marL="0">
               <a:buNone/>
             </a:pPr>
-            <a:endParaRPr lang="en-US" sz="2600" dirty="0"/>
+            <a:endParaRPr lang="en-US" sz="2000" dirty="0"/>
           </a:p>
         </p:txBody>
       </p:sp>
       <p:sp>
         <p:nvSpPr>
-          <p:cNvPr id="4" name="Text 1"/>
+          <p:cNvPr id="3" name="Text 0"/>
           <p:cNvSpPr/>
           <p:nvPr/>
         </p:nvSpPr>
         <p:spPr>
           <a:xfrm>
-            <a:off x="457200" y="4828032"/>
-            <a:ext cx="3657600" cy="182880"/>
+            <a:off x="6492240" y="201168"/>
+            <a:ext cx="2286000" cy="384048"/>
           </a:xfrm>
           <a:prstGeom prst="rect">
             <a:avLst/>
@@ -990,63 +672,18 @@
           <a:bodyPr wrap="square" lIns="0" tIns="0" rIns="0" bIns="0" rtlCol="0" anchor="ctr"/>
           <a:lstStyle/>
           <a:p>
-            <a:pPr indent="0" marL="0">
+            <a:pPr algn="r" indent="0" marL="0">
               <a:buNone/>
             </a:pPr>
             <a:r>
-              <a:rPr lang="en-US" sz="900" dirty="0">
+              <a:rPr lang="en-US" sz="1000" dirty="0">
                 <a:solidFill>
-                  <a:schemeClr val="accent3"/>
+                  <a:schemeClr val="tx2"/>
                 </a:solidFill>
               </a:rPr>
               <a:t>Spotkanie 12.10.2026</a:t>
             </a:r>
-            <a:endParaRPr lang="en-US" sz="900" dirty="0"/>
-          </a:p>
-        </p:txBody>
-      </p:sp>
-      <p:sp>
-        <p:nvSpPr>
-          <p:cNvPr id="25" name="Slide Number Placeholder 0"/>
-          <p:cNvSpPr>
-            <a:spLocks noGrp="1"/>
-          </p:cNvSpPr>
-          <p:nvPr>
-            <p:ph type="sldNum" sz="quarter" idx="4294967295"/>
-          </p:nvPr>
-        </p:nvSpPr>
-        <p:spPr>
-          <a:xfrm>
-            <a:off x="8321040" y="4828032"/>
-            <a:ext cx="365760" cy="182880"/>
-          </a:xfrm>
-          <a:prstGeom prst="rect">
-            <a:avLst/>
-          </a:prstGeom>
-          <a:extLst>
-            <a:ext uri="{C572A759-6A51-4108-AA02-DFA0A04FC94B}">
-              <ma14:wrappingTextBoxFlag xmlns:ma14="http://schemas.microsoft.com/office/mac/drawingml/2011/main" val="0"/>
-            </a:ext>
-          </a:extLst>
-        </p:spPr>
-        <p:txBody>
-          <a:bodyPr/>
-          <a:lstStyle>
-            <a:lvl1pPr>
-              <a:defRPr sz="900">
-                <a:solidFill>
-                  <a:schemeClr val="accent3"/>
-                </a:solidFill>
-              </a:defRPr>
-            </a:lvl1pPr>
-          </a:lstStyle>
-          <a:p>
-            <a:pPr algn="r"/>
-            <a:fld id="{F7021451-1387-4CA6-816F-3879F97B5CBC}" type="slidenum">
-              <a:rPr b="0" lang="en-US"/>
-              <a:t>1002</a:t>
-            </a:fld>
-            <a:endParaRPr lang="en-US"/>
+            <a:endParaRPr lang="en-US" sz="1000" dirty="0"/>
           </a:p>
         </p:txBody>
       </p:sp>
@@ -1075,51 +712,6 @@
           <a:chExt cx="0" cy="0"/>
         </a:xfrm>
       </p:grpSpPr>
-      <p:sp>
-        <p:nvSpPr>
-          <p:cNvPr id="25" name="Slide Number Placeholder 0"/>
-          <p:cNvSpPr>
-            <a:spLocks noGrp="1"/>
-          </p:cNvSpPr>
-          <p:nvPr>
-            <p:ph type="sldNum" sz="quarter" idx="4294967295"/>
-          </p:nvPr>
-        </p:nvSpPr>
-        <p:spPr>
-          <a:xfrm>
-            <a:off x="8321040" y="4828032"/>
-            <a:ext cx="365760" cy="182880"/>
-          </a:xfrm>
-          <a:prstGeom prst="rect">
-            <a:avLst/>
-          </a:prstGeom>
-          <a:extLst>
-            <a:ext uri="{C572A759-6A51-4108-AA02-DFA0A04FC94B}">
-              <ma14:wrappingTextBoxFlag xmlns:ma14="http://schemas.microsoft.com/office/mac/drawingml/2011/main" val="0"/>
-            </a:ext>
-          </a:extLst>
-        </p:spPr>
-        <p:txBody>
-          <a:bodyPr/>
-          <a:lstStyle>
-            <a:lvl1pPr>
-              <a:defRPr sz="900">
-                <a:solidFill>
-                  <a:schemeClr val="accent3"/>
-                </a:solidFill>
-              </a:defRPr>
-            </a:lvl1pPr>
-          </a:lstStyle>
-          <a:p>
-            <a:pPr algn="r"/>
-            <a:fld id="{F7021451-1387-4CA6-816F-3879F97B5CBC}" type="slidenum">
-              <a:rPr b="0" lang="en-US"/>
-              <a:t>null</a:t>
-            </a:fld>
-            <a:endParaRPr lang="en-US"/>
-          </a:p>
-        </p:txBody>
-      </p:sp>
     </p:spTree>
   </p:cSld>
   <p:clrMap bg1="lt1" tx1="dk1" bg2="lt2" tx2="dk2" accent1="accent1" accent2="accent2" accent3="accent3" accent4="accent4" accent5="accent5" accent6="accent6" hlink="hlink" folHlink="folHlink"/>
@@ -1400,16 +992,16 @@
       </p:grpSpPr>
       <p:sp>
         <p:nvSpPr>
-          <p:cNvPr id="2" name="Text 1"/>
+          <p:cNvPr id="2" name="Text 0"/>
           <p:cNvSpPr/>
           <p:nvPr>
-            <p:ph idx="101" type="title" hasCustomPrompt="1"/>
+            <p:ph idx="100" type="title" hasCustomPrompt="1"/>
           </p:nvPr>
         </p:nvSpPr>
         <p:spPr>
           <a:xfrm>
-            <a:off x="457200" y="502920"/>
-            <a:ext cx="8229600" cy="457200"/>
+            <a:off x="365760" y="201168"/>
+            <a:ext cx="6035040" cy="384048"/>
           </a:xfrm>
           <a:prstGeom prst="rect">
             <a:avLst/>
@@ -1418,21 +1010,21 @@
           <a:ln/>
         </p:spPr>
         <p:txBody>
-          <a:bodyPr wrap="square" lIns="0" tIns="0" rIns="0" bIns="0" rtlCol="0" anchor="t"/>
+          <a:bodyPr wrap="square" lIns="0" tIns="0" rIns="0" bIns="0" rtlCol="0" anchor="ctr"/>
           <a:lstStyle/>
           <a:p>
             <a:pPr algn="l" indent="0" marL="0">
               <a:buNone/>
             </a:pPr>
             <a:r>
-              <a:rPr lang="en-US" sz="2600" b="1" dirty="0">
+              <a:rPr lang="en-US" sz="2000" b="1" dirty="0">
                 <a:solidFill>
                   <a:schemeClr val="accent1"/>
                 </a:solidFill>
               </a:rPr>
-              <a:t>Partnerzy instytucjonalni</a:t>
+              <a:t>Status projektu GAia – stan na 5.10.2026</a:t>
             </a:r>
-            <a:endParaRPr lang="en-US" sz="2600" dirty="0"/>
+            <a:endParaRPr lang="en-US" sz="2000" dirty="0"/>
           </a:p>
         </p:txBody>
       </p:sp>
@@ -1451,16 +1043,16 @@
           </p:nvPr>
         </p:nvGraphicFramePr>
         <p:xfrm>
-          <a:off x="457200" y="1188720"/>
-          <a:ext cx="8229600" cy="914400"/>
+          <a:off x="365760" y="731520"/>
+          <a:ext cx="8412480" cy="914400"/>
         </p:xfrm>
         <a:graphic>
           <a:graphicData uri="http://schemas.openxmlformats.org/drawingml/2006/table">
             <a:tbl>
               <a:tblPr/>
               <a:tblGrid>
-                <a:gridCol w="1554480"/>
-                <a:gridCol w="4023360"/>
+                <a:gridCol w="1417320"/>
+                <a:gridCol w="4343400"/>
                 <a:gridCol w="2651760"/>
               </a:tblGrid>
               <a:tr h="0">
@@ -1473,17 +1065,17 @@
                         <a:buNone/>
                       </a:pPr>
                       <a:r>
-                        <a:rPr lang="en-US" sz="1200" b="1" dirty="0">
+                        <a:rPr lang="en-US" sz="1000" b="1" dirty="0">
                           <a:solidFill>
                             <a:schemeClr val="bg1"/>
                           </a:solidFill>
                         </a:rPr>
                         <a:t>Podmiot</a:t>
                       </a:r>
-                      <a:endParaRPr lang="en-US" sz="1200" dirty="0"/>
+                      <a:endParaRPr lang="en-US" sz="1000" dirty="0"/>
                     </a:p>
                   </a:txBody>
-                  <a:tcPr marL="91440" marR="91440" marT="54864" marB="54864" anchor="ctr">
+                  <a:tcPr marL="73152" marR="73152" marT="27432" marB="27432" anchor="ctr">
                     <a:lnL w="9525" cap="flat" cmpd="sng" algn="ctr">
                       <a:solidFill>
                         <a:srgbClr val="D5DBE2"/>
@@ -1534,17 +1126,17 @@
                         <a:buNone/>
                       </a:pPr>
                       <a:r>
-                        <a:rPr lang="en-US" sz="1200" b="1" dirty="0">
+                        <a:rPr lang="en-US" sz="1000" b="1" dirty="0">
                           <a:solidFill>
                             <a:schemeClr val="bg1"/>
                           </a:solidFill>
                         </a:rPr>
                         <a:t>Etap</a:t>
                       </a:r>
-                      <a:endParaRPr lang="en-US" sz="1200" dirty="0"/>
+                      <a:endParaRPr lang="en-US" sz="1000" dirty="0"/>
                     </a:p>
                   </a:txBody>
-                  <a:tcPr marL="91440" marR="91440" marT="54864" marB="54864" anchor="ctr">
+                  <a:tcPr marL="73152" marR="73152" marT="27432" marB="27432" anchor="ctr">
                     <a:lnL w="9525" cap="flat" cmpd="sng" algn="ctr">
                       <a:solidFill>
                         <a:srgbClr val="D5DBE2"/>
@@ -1595,17 +1187,17 @@
                         <a:buNone/>
                       </a:pPr>
                       <a:r>
-                        <a:rPr lang="en-US" sz="1200" b="1" dirty="0">
+                        <a:rPr lang="en-US" sz="1000" b="1" dirty="0">
                           <a:solidFill>
                             <a:schemeClr val="bg1"/>
                           </a:solidFill>
                         </a:rPr>
                         <a:t>Do dyskusji</a:t>
                       </a:r>
-                      <a:endParaRPr lang="en-US" sz="1200" dirty="0"/>
+                      <a:endParaRPr lang="en-US" sz="1000" dirty="0"/>
                     </a:p>
                   </a:txBody>
-                  <a:tcPr marL="91440" marR="91440" marT="54864" marB="54864" anchor="ctr">
+                  <a:tcPr marL="73152" marR="73152" marT="27432" marB="27432" anchor="ctr">
                     <a:lnL w="9525" cap="flat" cmpd="sng" algn="ctr">
                       <a:solidFill>
                         <a:srgbClr val="D5DBE2"/>
@@ -1646,6 +1238,75 @@
                       <a:schemeClr val="accent2"/>
                     </a:solidFill>
                   </a:tcPr>
+                </a:tc>
+              </a:tr>
+              <a:tr h="0">
+                <a:tc gridSpan="3">
+                  <a:txBody>
+                    <a:bodyPr/>
+                    <a:lstStyle/>
+                    <a:p>
+                      <a:pPr indent="0" marL="0">
+                        <a:buNone/>
+                      </a:pPr>
+                      <a:r>
+                        <a:rPr lang="en-US" sz="850" b="1" spc="100" kern="0" dirty="0">
+                          <a:solidFill>
+                            <a:schemeClr val="accent1"/>
+                          </a:solidFill>
+                        </a:rPr>
+                        <a:t>PARTNERZY INSTYTUCJONALNI</a:t>
+                      </a:r>
+                      <a:endParaRPr lang="en-US" sz="850" dirty="0"/>
+                    </a:p>
+                  </a:txBody>
+                  <a:tcPr marL="73152" marR="73152" marT="27432" marB="27432" anchor="ctr">
+                    <a:lnL w="9525" cap="flat" cmpd="sng" algn="ctr">
+                      <a:solidFill>
+                        <a:srgbClr val="D5DBE2"/>
+                      </a:solidFill>
+                      <a:prstDash val="solid"/>
+                      <a:round/>
+                      <a:headEnd type="none" w="med" len="med"/>
+                      <a:tailEnd type="none" w="med" len="med"/>
+                    </a:lnL>
+                    <a:lnR w="9525" cap="flat" cmpd="sng" algn="ctr">
+                      <a:solidFill>
+                        <a:srgbClr val="D5DBE2"/>
+                      </a:solidFill>
+                      <a:prstDash val="solid"/>
+                      <a:round/>
+                      <a:headEnd type="none" w="med" len="med"/>
+                      <a:tailEnd type="none" w="med" len="med"/>
+                    </a:lnR>
+                    <a:lnT w="9525" cap="flat" cmpd="sng" algn="ctr">
+                      <a:solidFill>
+                        <a:srgbClr val="D5DBE2"/>
+                      </a:solidFill>
+                      <a:prstDash val="solid"/>
+                      <a:round/>
+                      <a:headEnd type="none" w="med" len="med"/>
+                      <a:tailEnd type="none" w="med" len="med"/>
+                    </a:lnT>
+                    <a:lnB w="9525" cap="flat" cmpd="sng" algn="ctr">
+                      <a:solidFill>
+                        <a:srgbClr val="D5DBE2"/>
+                      </a:solidFill>
+                      <a:prstDash val="solid"/>
+                      <a:round/>
+                      <a:headEnd type="none" w="med" len="med"/>
+                      <a:tailEnd type="none" w="med" len="med"/>
+                    </a:lnB>
+                    <a:solidFill>
+                      <a:schemeClr val="bg2"/>
+                    </a:solidFill>
+                  </a:tcPr>
+                </a:tc>
+                <a:tc hMerge="1">
+                  <a:tcPr/>
+                </a:tc>
+                <a:tc hMerge="1">
+                  <a:tcPr/>
                 </a:tc>
               </a:tr>
               <a:tr h="0">
@@ -1658,17 +1319,17 @@
                         <a:buNone/>
                       </a:pPr>
                       <a:r>
-                        <a:rPr lang="en-US" sz="1400" b="1" dirty="0">
+                        <a:rPr lang="en-US" sz="950" b="1" dirty="0">
                           <a:solidFill>
                             <a:schemeClr val="tx1"/>
                           </a:solidFill>
                         </a:rPr>
                         <a:t>Ministerstwo Cyfryzacji</a:t>
                       </a:r>
-                      <a:endParaRPr lang="en-US" sz="1400" dirty="0"/>
+                      <a:endParaRPr lang="en-US" sz="950" dirty="0"/>
                     </a:p>
                   </a:txBody>
-                  <a:tcPr marL="91440" marR="91440" marT="54864" marB="54864" anchor="t">
+                  <a:tcPr marL="73152" marR="73152" marT="27432" marB="27432" anchor="ctr">
                     <a:lnL w="9525" cap="flat" cmpd="sng" algn="ctr">
                       <a:solidFill>
                         <a:srgbClr val="D5DBE2"/>
@@ -1716,17 +1377,17 @@
                         <a:buNone/>
                       </a:pPr>
                       <a:r>
-                        <a:rPr lang="en-US" sz="1300" dirty="0">
+                        <a:rPr lang="en-US" sz="950" dirty="0">
                           <a:solidFill>
                             <a:schemeClr val="tx1"/>
                           </a:solidFill>
                         </a:rPr>
                         <a:t>Porozumienie podpisane, korespondencja wysłana. Oczekujemy na odpowiedź i powołanie dedykowanego zespołu po stronie Ministerstwa.</a:t>
                       </a:r>
-                      <a:endParaRPr lang="en-US" sz="1300" dirty="0"/>
+                      <a:endParaRPr lang="en-US" sz="950" dirty="0"/>
                     </a:p>
                   </a:txBody>
-                  <a:tcPr marL="91440" marR="91440" marT="54864" marB="54864" anchor="t">
+                  <a:tcPr marL="73152" marR="73152" marT="27432" marB="27432" anchor="ctr">
                     <a:lnL w="9525" cap="flat" cmpd="sng" algn="ctr">
                       <a:solidFill>
                         <a:srgbClr val="D5DBE2"/>
@@ -1773,18 +1434,10 @@
                       <a:pPr indent="0" marL="0">
                         <a:buNone/>
                       </a:pPr>
-                      <a:r>
-                        <a:rPr lang="en-US" sz="1300" dirty="0">
-                          <a:solidFill>
-                            <a:schemeClr val="accent3"/>
-                          </a:solidFill>
-                        </a:rPr>
-                        <a:t>–</a:t>
-                      </a:r>
-                      <a:endParaRPr lang="en-US" sz="1300" dirty="0"/>
+                      <a:endParaRPr lang="en-US" sz="950" dirty="0"/>
                     </a:p>
                   </a:txBody>
-                  <a:tcPr marL="91440" marR="91440" marT="54864" marB="54864" anchor="t">
+                  <a:tcPr marL="73152" marR="73152" marT="27432" marB="27432" anchor="ctr">
                     <a:lnL w="9525" cap="flat" cmpd="sng" algn="ctr">
                       <a:solidFill>
                         <a:srgbClr val="D5DBE2"/>
@@ -1837,17 +1490,17 @@
                         <a:buNone/>
                       </a:pPr>
                       <a:r>
-                        <a:rPr lang="en-US" sz="1400" b="1" dirty="0">
+                        <a:rPr lang="en-US" sz="950" b="1" dirty="0">
                           <a:solidFill>
                             <a:schemeClr val="tx1"/>
                           </a:solidFill>
                         </a:rPr>
                         <a:t>Ministerstwo Rolnictwa i ARiMR</a:t>
                       </a:r>
-                      <a:endParaRPr lang="en-US" sz="1400" dirty="0"/>
+                      <a:endParaRPr lang="en-US" sz="950" dirty="0"/>
                     </a:p>
                   </a:txBody>
-                  <a:tcPr marL="91440" marR="91440" marT="54864" marB="54864" anchor="t">
+                  <a:tcPr marL="73152" marR="73152" marT="27432" marB="27432" anchor="ctr">
                     <a:lnL w="9525" cap="flat" cmpd="sng" algn="ctr">
                       <a:solidFill>
                         <a:srgbClr val="D5DBE2"/>
@@ -1895,17 +1548,17 @@
                         <a:buNone/>
                       </a:pPr>
                       <a:r>
-                        <a:rPr lang="en-US" sz="1300" dirty="0">
+                        <a:rPr lang="en-US" sz="950" dirty="0">
                           <a:solidFill>
                             <a:schemeClr val="tx1"/>
                           </a:solidFill>
                         </a:rPr>
                         <a:t>Porozumienie podpisane, korespondencja wysłana. Oczekujemy na harmonogram działań i wskazanie zespołu projektowego po stronie partnera.</a:t>
                       </a:r>
-                      <a:endParaRPr lang="en-US" sz="1300" dirty="0"/>
+                      <a:endParaRPr lang="en-US" sz="950" dirty="0"/>
                     </a:p>
                   </a:txBody>
-                  <a:tcPr marL="91440" marR="91440" marT="54864" marB="54864" anchor="t">
+                  <a:tcPr marL="73152" marR="73152" marT="27432" marB="27432" anchor="ctr">
                     <a:lnL w="9525" cap="flat" cmpd="sng" algn="ctr">
                       <a:solidFill>
                         <a:srgbClr val="D5DBE2"/>
@@ -1952,18 +1605,10 @@
                       <a:pPr indent="0" marL="0">
                         <a:buNone/>
                       </a:pPr>
-                      <a:r>
-                        <a:rPr lang="en-US" sz="1300" dirty="0">
-                          <a:solidFill>
-                            <a:schemeClr val="accent3"/>
-                          </a:solidFill>
-                        </a:rPr>
-                        <a:t>–</a:t>
-                      </a:r>
-                      <a:endParaRPr lang="en-US" sz="1300" dirty="0"/>
+                      <a:endParaRPr lang="en-US" sz="950" dirty="0"/>
                     </a:p>
                   </a:txBody>
-                  <a:tcPr marL="91440" marR="91440" marT="54864" marB="54864" anchor="t">
+                  <a:tcPr marL="73152" marR="73152" marT="27432" marB="27432" anchor="ctr">
                     <a:lnL w="9525" cap="flat" cmpd="sng" algn="ctr">
                       <a:solidFill>
                         <a:srgbClr val="D5DBE2"/>
@@ -2016,17 +1661,17 @@
                         <a:buNone/>
                       </a:pPr>
                       <a:r>
-                        <a:rPr lang="en-US" sz="1400" b="1" dirty="0">
+                        <a:rPr lang="en-US" sz="950" b="1" dirty="0">
                           <a:solidFill>
                             <a:schemeClr val="tx1"/>
                           </a:solidFill>
                         </a:rPr>
                         <a:t>ARiMR</a:t>
                       </a:r>
-                      <a:endParaRPr lang="en-US" sz="1400" dirty="0"/>
+                      <a:endParaRPr lang="en-US" sz="950" dirty="0"/>
                     </a:p>
                   </a:txBody>
-                  <a:tcPr marL="91440" marR="91440" marT="54864" marB="54864" anchor="t">
+                  <a:tcPr marL="73152" marR="73152" marT="27432" marB="27432" anchor="ctr">
                     <a:lnL w="9525" cap="flat" cmpd="sng" algn="ctr">
                       <a:solidFill>
                         <a:srgbClr val="D5DBE2"/>
@@ -2074,17 +1719,17 @@
                         <a:buNone/>
                       </a:pPr>
                       <a:r>
-                        <a:rPr lang="en-US" sz="1300" dirty="0">
+                        <a:rPr lang="en-US" sz="950" dirty="0">
                           <a:solidFill>
                             <a:schemeClr val="tx1"/>
                           </a:solidFill>
                         </a:rPr>
                         <a:t>Spotkanie 13.10 w siedzibie ARiMR w sprawie porozumienia międzyministerialnego i dalszych kroków uzyskania dostępu do bazy danych rolników.</a:t>
                       </a:r>
-                      <a:endParaRPr lang="en-US" sz="1300" dirty="0"/>
+                      <a:endParaRPr lang="en-US" sz="950" dirty="0"/>
                     </a:p>
                   </a:txBody>
-                  <a:tcPr marL="91440" marR="91440" marT="54864" marB="54864" anchor="t">
+                  <a:tcPr marL="73152" marR="73152" marT="27432" marB="27432" anchor="ctr">
                     <a:lnL w="9525" cap="flat" cmpd="sng" algn="ctr">
                       <a:solidFill>
                         <a:srgbClr val="D5DBE2"/>
@@ -2132,17 +1777,17 @@
                         <a:buNone/>
                       </a:pPr>
                       <a:r>
-                        <a:rPr lang="en-US" sz="1300" b="1" dirty="0">
+                        <a:rPr lang="en-US" sz="950" b="1" dirty="0">
                           <a:solidFill>
                             <a:schemeClr val="accent2"/>
                           </a:solidFill>
                         </a:rPr>
                         <a:t>Na co możemy się zgodzić we współpracy z ARiMR przy budowie Portalu Rolnika?</a:t>
                       </a:r>
-                      <a:endParaRPr lang="en-US" sz="1300" dirty="0"/>
+                      <a:endParaRPr lang="en-US" sz="950" dirty="0"/>
                     </a:p>
                   </a:txBody>
-                  <a:tcPr marL="91440" marR="91440" marT="54864" marB="54864" anchor="t">
+                  <a:tcPr marL="73152" marR="73152" marT="27432" marB="27432" anchor="ctr">
                     <a:lnL w="9525" cap="flat" cmpd="sng" algn="ctr">
                       <a:solidFill>
                         <a:srgbClr val="D5DBE2"/>
@@ -2185,147 +1830,8 @@
                   </a:tcPr>
                 </a:tc>
               </a:tr>
-            </a:tbl>
-          </a:graphicData>
-        </a:graphic>
-      </p:graphicFrame>
-      <p:sp>
-        <p:nvSpPr>
-          <p:cNvPr id="25" name="Slide Number Placeholder 0"/>
-          <p:cNvSpPr>
-            <a:spLocks noGrp="1"/>
-          </p:cNvSpPr>
-          <p:nvPr>
-            <p:ph type="sldNum" sz="quarter" idx="4294967295"/>
-          </p:nvPr>
-        </p:nvSpPr>
-        <p:spPr>
-          <a:xfrm>
-            <a:off x="8321040" y="4828032"/>
-            <a:ext cx="365760" cy="182880"/>
-          </a:xfrm>
-          <a:prstGeom prst="rect">
-            <a:avLst/>
-          </a:prstGeom>
-          <a:extLst>
-            <a:ext uri="{C572A759-6A51-4108-AA02-DFA0A04FC94B}">
-              <ma14:wrappingTextBoxFlag xmlns:ma14="http://schemas.microsoft.com/office/mac/drawingml/2011/main" val="0"/>
-            </a:ext>
-          </a:extLst>
-        </p:spPr>
-        <p:txBody>
-          <a:bodyPr/>
-          <a:lstStyle>
-            <a:lvl1pPr>
-              <a:defRPr sz="900">
-                <a:solidFill>
-                  <a:schemeClr val="accent3"/>
-                </a:solidFill>
-              </a:defRPr>
-            </a:lvl1pPr>
-          </a:lstStyle>
-          <a:p>
-            <a:pPr algn="r"/>
-            <a:fld id="{F7021451-1387-4CA6-816F-3879F97B5CBC}" type="slidenum">
-              <a:rPr b="0" lang="en-US"/>
-              <a:t>1</a:t>
-            </a:fld>
-            <a:endParaRPr lang="en-US"/>
-          </a:p>
-        </p:txBody>
-      </p:sp>
-    </p:spTree>
-  </p:cSld>
-  <p:clrMapOvr>
-    <a:masterClrMapping/>
-  </p:clrMapOvr>
-</p:sld>
-</file>
-
-<file path=ppt/slides/slide2.xml><?xml version="1.0" encoding="utf-8"?>
-<p:sld xmlns:a="http://schemas.openxmlformats.org/drawingml/2006/main" xmlns:r="http://schemas.openxmlformats.org/officeDocument/2006/relationships" xmlns:p="http://schemas.openxmlformats.org/presentationml/2006/main">
-  <p:cSld name="Slide 2">
-    <p:spTree>
-      <p:nvGrpSpPr>
-        <p:cNvPr id="1" name=""/>
-        <p:cNvGrpSpPr/>
-        <p:nvPr/>
-      </p:nvGrpSpPr>
-      <p:grpSpPr>
-        <a:xfrm>
-          <a:off x="0" y="0"/>
-          <a:ext cx="0" cy="0"/>
-          <a:chOff x="0" y="0"/>
-          <a:chExt cx="0" cy="0"/>
-        </a:xfrm>
-      </p:grpSpPr>
-      <p:sp>
-        <p:nvSpPr>
-          <p:cNvPr id="2" name="Text 1"/>
-          <p:cNvSpPr/>
-          <p:nvPr>
-            <p:ph idx="101" type="title" hasCustomPrompt="1"/>
-          </p:nvPr>
-        </p:nvSpPr>
-        <p:spPr>
-          <a:xfrm>
-            <a:off x="457200" y="502920"/>
-            <a:ext cx="8229600" cy="457200"/>
-          </a:xfrm>
-          <a:prstGeom prst="rect">
-            <a:avLst/>
-          </a:prstGeom>
-          <a:noFill/>
-          <a:ln/>
-        </p:spPr>
-        <p:txBody>
-          <a:bodyPr wrap="square" lIns="0" tIns="0" rIns="0" bIns="0" rtlCol="0" anchor="t"/>
-          <a:lstStyle/>
-          <a:p>
-            <a:pPr algn="l" indent="0" marL="0">
-              <a:buNone/>
-            </a:pPr>
-            <a:r>
-              <a:rPr lang="en-US" sz="2600" b="1" dirty="0">
-                <a:solidFill>
-                  <a:schemeClr val="accent1"/>
-                </a:solidFill>
-              </a:rPr>
-              <a:t>Partnerzy komercyjni</a:t>
-            </a:r>
-            <a:endParaRPr lang="en-US" sz="2600" dirty="0"/>
-          </a:p>
-        </p:txBody>
-      </p:sp>
-      <p:graphicFrame>
-        <p:nvGraphicFramePr>
-          <p:cNvPr id="3" name="Tabela statusu"/>
-          <p:cNvGraphicFramePr>
-            <a:graphicFrameLocks noGrp="1"/>
-          </p:cNvGraphicFramePr>
-          <p:nvPr>
-            <p:extLst>
-              <p:ext uri="{D42A27DB-BD31-4B8C-83A1-F6EECF244321}">
-                <p14:modId xmlns:p14="http://schemas.microsoft.com/office/powerpoint/2010/main" val="1579011935"/>
-              </p:ext>
-            </p:extLst>
-          </p:nvPr>
-        </p:nvGraphicFramePr>
-        <p:xfrm>
-          <a:off x="457200" y="1188720"/>
-          <a:ext cx="8229600" cy="914400"/>
-        </p:xfrm>
-        <a:graphic>
-          <a:graphicData uri="http://schemas.openxmlformats.org/drawingml/2006/table">
-            <a:tbl>
-              <a:tblPr/>
-              <a:tblGrid>
-                <a:gridCol w="1554480"/>
-                <a:gridCol w="4023360"/>
-                <a:gridCol w="2651760"/>
-              </a:tblGrid>
               <a:tr h="0">
-                <a:tc>
+                <a:tc gridSpan="3">
                   <a:txBody>
                     <a:bodyPr/>
                     <a:lstStyle/>
@@ -2334,17 +1840,17 @@
                         <a:buNone/>
                       </a:pPr>
                       <a:r>
-                        <a:rPr lang="en-US" sz="1200" b="1" dirty="0">
+                        <a:rPr lang="en-US" sz="850" b="1" spc="100" kern="0" dirty="0">
                           <a:solidFill>
-                            <a:schemeClr val="bg1"/>
+                            <a:schemeClr val="accent1"/>
                           </a:solidFill>
                         </a:rPr>
-                        <a:t>Podmiot</a:t>
+                        <a:t>PARTNERZY KOMERCYJNI</a:t>
                       </a:r>
-                      <a:endParaRPr lang="en-US" sz="1200" dirty="0"/>
+                      <a:endParaRPr lang="en-US" sz="850" dirty="0"/>
                     </a:p>
                   </a:txBody>
-                  <a:tcPr marL="91440" marR="91440" marT="54864" marB="54864" anchor="ctr">
+                  <a:tcPr marL="73152" marR="73152" marT="27432" marB="27432" anchor="ctr">
                     <a:lnL w="9525" cap="flat" cmpd="sng" algn="ctr">
                       <a:solidFill>
                         <a:srgbClr val="D5DBE2"/>
@@ -2382,131 +1888,15 @@
                       <a:tailEnd type="none" w="med" len="med"/>
                     </a:lnB>
                     <a:solidFill>
-                      <a:schemeClr val="accent1"/>
+                      <a:schemeClr val="bg2"/>
                     </a:solidFill>
                   </a:tcPr>
                 </a:tc>
-                <a:tc>
-                  <a:txBody>
-                    <a:bodyPr/>
-                    <a:lstStyle/>
-                    <a:p>
-                      <a:pPr indent="0" marL="0">
-                        <a:buNone/>
-                      </a:pPr>
-                      <a:r>
-                        <a:rPr lang="en-US" sz="1200" b="1" dirty="0">
-                          <a:solidFill>
-                            <a:schemeClr val="bg1"/>
-                          </a:solidFill>
-                        </a:rPr>
-                        <a:t>Etap</a:t>
-                      </a:r>
-                      <a:endParaRPr lang="en-US" sz="1200" dirty="0"/>
-                    </a:p>
-                  </a:txBody>
-                  <a:tcPr marL="91440" marR="91440" marT="54864" marB="54864" anchor="ctr">
-                    <a:lnL w="9525" cap="flat" cmpd="sng" algn="ctr">
-                      <a:solidFill>
-                        <a:srgbClr val="D5DBE2"/>
-                      </a:solidFill>
-                      <a:prstDash val="solid"/>
-                      <a:round/>
-                      <a:headEnd type="none" w="med" len="med"/>
-                      <a:tailEnd type="none" w="med" len="med"/>
-                    </a:lnL>
-                    <a:lnR w="9525" cap="flat" cmpd="sng" algn="ctr">
-                      <a:solidFill>
-                        <a:srgbClr val="D5DBE2"/>
-                      </a:solidFill>
-                      <a:prstDash val="solid"/>
-                      <a:round/>
-                      <a:headEnd type="none" w="med" len="med"/>
-                      <a:tailEnd type="none" w="med" len="med"/>
-                    </a:lnR>
-                    <a:lnT w="9525" cap="flat" cmpd="sng" algn="ctr">
-                      <a:solidFill>
-                        <a:srgbClr val="D5DBE2"/>
-                      </a:solidFill>
-                      <a:prstDash val="solid"/>
-                      <a:round/>
-                      <a:headEnd type="none" w="med" len="med"/>
-                      <a:tailEnd type="none" w="med" len="med"/>
-                    </a:lnT>
-                    <a:lnB w="9525" cap="flat" cmpd="sng" algn="ctr">
-                      <a:solidFill>
-                        <a:srgbClr val="D5DBE2"/>
-                      </a:solidFill>
-                      <a:prstDash val="solid"/>
-                      <a:round/>
-                      <a:headEnd type="none" w="med" len="med"/>
-                      <a:tailEnd type="none" w="med" len="med"/>
-                    </a:lnB>
-                    <a:solidFill>
-                      <a:schemeClr val="accent1"/>
-                    </a:solidFill>
-                  </a:tcPr>
-                </a:tc>
-                <a:tc>
-                  <a:txBody>
-                    <a:bodyPr/>
-                    <a:lstStyle/>
-                    <a:p>
-                      <a:pPr indent="0" marL="0">
-                        <a:buNone/>
-                      </a:pPr>
-                      <a:r>
-                        <a:rPr lang="en-US" sz="1200" b="1" dirty="0">
-                          <a:solidFill>
-                            <a:schemeClr val="bg1"/>
-                          </a:solidFill>
-                        </a:rPr>
-                        <a:t>Do dyskusji</a:t>
-                      </a:r>
-                      <a:endParaRPr lang="en-US" sz="1200" dirty="0"/>
-                    </a:p>
-                  </a:txBody>
-                  <a:tcPr marL="91440" marR="91440" marT="54864" marB="54864" anchor="ctr">
-                    <a:lnL w="9525" cap="flat" cmpd="sng" algn="ctr">
-                      <a:solidFill>
-                        <a:srgbClr val="D5DBE2"/>
-                      </a:solidFill>
-                      <a:prstDash val="solid"/>
-                      <a:round/>
-                      <a:headEnd type="none" w="med" len="med"/>
-                      <a:tailEnd type="none" w="med" len="med"/>
-                    </a:lnL>
-                    <a:lnR w="9525" cap="flat" cmpd="sng" algn="ctr">
-                      <a:solidFill>
-                        <a:srgbClr val="D5DBE2"/>
-                      </a:solidFill>
-                      <a:prstDash val="solid"/>
-                      <a:round/>
-                      <a:headEnd type="none" w="med" len="med"/>
-                      <a:tailEnd type="none" w="med" len="med"/>
-                    </a:lnR>
-                    <a:lnT w="9525" cap="flat" cmpd="sng" algn="ctr">
-                      <a:solidFill>
-                        <a:srgbClr val="D5DBE2"/>
-                      </a:solidFill>
-                      <a:prstDash val="solid"/>
-                      <a:round/>
-                      <a:headEnd type="none" w="med" len="med"/>
-                      <a:tailEnd type="none" w="med" len="med"/>
-                    </a:lnT>
-                    <a:lnB w="9525" cap="flat" cmpd="sng" algn="ctr">
-                      <a:solidFill>
-                        <a:srgbClr val="D5DBE2"/>
-                      </a:solidFill>
-                      <a:prstDash val="solid"/>
-                      <a:round/>
-                      <a:headEnd type="none" w="med" len="med"/>
-                      <a:tailEnd type="none" w="med" len="med"/>
-                    </a:lnB>
-                    <a:solidFill>
-                      <a:schemeClr val="accent2"/>
-                    </a:solidFill>
-                  </a:tcPr>
+                <a:tc hMerge="1">
+                  <a:tcPr/>
+                </a:tc>
+                <a:tc hMerge="1">
+                  <a:tcPr/>
                 </a:tc>
               </a:tr>
               <a:tr h="0">
@@ -2519,17 +1909,17 @@
                         <a:buNone/>
                       </a:pPr>
                       <a:r>
-                        <a:rPr lang="en-US" sz="1300" b="1" dirty="0">
+                        <a:rPr lang="en-US" sz="950" b="1" dirty="0">
                           <a:solidFill>
                             <a:schemeClr val="tx1"/>
                           </a:solidFill>
                         </a:rPr>
                         <a:t>Empik</a:t>
                       </a:r>
-                      <a:endParaRPr lang="en-US" sz="1300" dirty="0"/>
+                      <a:endParaRPr lang="en-US" sz="950" dirty="0"/>
                     </a:p>
                   </a:txBody>
-                  <a:tcPr marL="91440" marR="91440" marT="54864" marB="54864" anchor="t">
+                  <a:tcPr marL="73152" marR="73152" marT="27432" marB="27432" anchor="ctr">
                     <a:lnL w="9525" cap="flat" cmpd="sng" algn="ctr">
                       <a:solidFill>
                         <a:srgbClr val="D5DBE2"/>
@@ -2577,17 +1967,17 @@
                         <a:buNone/>
                       </a:pPr>
                       <a:r>
-                        <a:rPr lang="en-US" sz="1200" dirty="0">
+                        <a:rPr lang="en-US" sz="950" dirty="0">
                           <a:solidFill>
                             <a:schemeClr val="tx1"/>
                           </a:solidFill>
                         </a:rPr>
                         <a:t>Spotkania odbyte, jest wstępne zainteresowanie udziałem w projekcie. Partner buduje dedykowany zespół.</a:t>
                       </a:r>
-                      <a:endParaRPr lang="en-US" sz="1200" dirty="0"/>
+                      <a:endParaRPr lang="en-US" sz="950" dirty="0"/>
                     </a:p>
                   </a:txBody>
-                  <a:tcPr marL="91440" marR="91440" marT="54864" marB="54864" anchor="t">
+                  <a:tcPr marL="73152" marR="73152" marT="27432" marB="27432" anchor="ctr">
                     <a:lnL w="9525" cap="flat" cmpd="sng" algn="ctr">
                       <a:solidFill>
                         <a:srgbClr val="D5DBE2"/>
@@ -2635,17 +2025,17 @@
                         <a:buNone/>
                       </a:pPr>
                       <a:r>
-                        <a:rPr lang="en-US" sz="1200" b="1" dirty="0">
+                        <a:rPr lang="en-US" sz="950" b="1" dirty="0">
                           <a:solidFill>
                             <a:schemeClr val="accent2"/>
                           </a:solidFill>
                         </a:rPr>
-                        <a:t>Czy zostało coś ustalone poza spotkaniami, o czym powinniśmy wiedzieć? Na jakim poziomie jest aktualnie zainteresowanie?</a:t>
+                        <a:t>Czy zostało coś ustalone poza spotkaniami, o czym powinniśmy wiedzieć? Jaki jest aktualnie poziom zainteresowania?</a:t>
                       </a:r>
-                      <a:endParaRPr lang="en-US" sz="1200" dirty="0"/>
+                      <a:endParaRPr lang="en-US" sz="950" dirty="0"/>
                     </a:p>
                   </a:txBody>
-                  <a:tcPr marL="91440" marR="91440" marT="54864" marB="54864" anchor="t">
+                  <a:tcPr marL="73152" marR="73152" marT="27432" marB="27432" anchor="ctr">
                     <a:lnL w="9525" cap="flat" cmpd="sng" algn="ctr">
                       <a:solidFill>
                         <a:srgbClr val="D5DBE2"/>
@@ -2698,17 +2088,17 @@
                         <a:buNone/>
                       </a:pPr>
                       <a:r>
-                        <a:rPr lang="en-US" sz="1300" b="1" dirty="0">
+                        <a:rPr lang="en-US" sz="950" b="1" dirty="0">
                           <a:solidFill>
                             <a:schemeClr val="tx1"/>
                           </a:solidFill>
                         </a:rPr>
                         <a:t>PZU</a:t>
                       </a:r>
-                      <a:endParaRPr lang="en-US" sz="1300" dirty="0"/>
+                      <a:endParaRPr lang="en-US" sz="950" dirty="0"/>
                     </a:p>
                   </a:txBody>
-                  <a:tcPr marL="91440" marR="91440" marT="54864" marB="54864" anchor="t">
+                  <a:tcPr marL="73152" marR="73152" marT="27432" marB="27432" anchor="ctr">
                     <a:lnL w="9525" cap="flat" cmpd="sng" algn="ctr">
                       <a:solidFill>
                         <a:srgbClr val="D5DBE2"/>
@@ -2756,17 +2146,17 @@
                         <a:buNone/>
                       </a:pPr>
                       <a:r>
-                        <a:rPr lang="en-US" sz="1200" dirty="0">
+                        <a:rPr lang="en-US" sz="950" dirty="0">
                           <a:solidFill>
                             <a:schemeClr val="tx1"/>
                           </a:solidFill>
                         </a:rPr>
                         <a:t>Spotkanie z Dyrektorem ds. ubezpieczeń dla rolników. PZU przygotowuje wewnętrznie propozycję oferty ubezpieczeniowej. Najlepszym rozwiązaniem będzie moduł wewnątrz aplikacji, bez przekierowania do partnera.</a:t>
                       </a:r>
-                      <a:endParaRPr lang="en-US" sz="1200" dirty="0"/>
+                      <a:endParaRPr lang="en-US" sz="950" dirty="0"/>
                     </a:p>
                   </a:txBody>
-                  <a:tcPr marL="91440" marR="91440" marT="54864" marB="54864" anchor="t">
+                  <a:tcPr marL="73152" marR="73152" marT="27432" marB="27432" anchor="ctr">
                     <a:lnL w="9525" cap="flat" cmpd="sng" algn="ctr">
                       <a:solidFill>
                         <a:srgbClr val="D5DBE2"/>
@@ -2814,17 +2204,17 @@
                         <a:buNone/>
                       </a:pPr>
                       <a:r>
-                        <a:rPr lang="en-US" sz="1200" b="1" dirty="0">
+                        <a:rPr lang="en-US" sz="950" b="1" dirty="0">
                           <a:solidFill>
                             <a:schemeClr val="accent2"/>
                           </a:solidFill>
                         </a:rPr>
                         <a:t>Czy możemy rozmawiać z PZU o rozszerzeniu wsparcia również o finansowanie i inwestycje?</a:t>
                       </a:r>
-                      <a:endParaRPr lang="en-US" sz="1200" dirty="0"/>
+                      <a:endParaRPr lang="en-US" sz="950" dirty="0"/>
                     </a:p>
                   </a:txBody>
-                  <a:tcPr marL="91440" marR="91440" marT="54864" marB="54864" anchor="t">
+                  <a:tcPr marL="73152" marR="73152" marT="27432" marB="27432" anchor="ctr">
                     <a:lnL w="9525" cap="flat" cmpd="sng" algn="ctr">
                       <a:solidFill>
                         <a:srgbClr val="D5DBE2"/>
@@ -2877,17 +2267,17 @@
                         <a:buNone/>
                       </a:pPr>
                       <a:r>
-                        <a:rPr lang="en-US" sz="1300" b="1" dirty="0">
+                        <a:rPr lang="en-US" sz="950" b="1" dirty="0">
                           <a:solidFill>
                             <a:schemeClr val="tx1"/>
                           </a:solidFill>
                         </a:rPr>
                         <a:t>Euro RTV AGD</a:t>
                       </a:r>
-                      <a:endParaRPr lang="en-US" sz="1300" dirty="0"/>
+                      <a:endParaRPr lang="en-US" sz="950" dirty="0"/>
                     </a:p>
                   </a:txBody>
-                  <a:tcPr marL="91440" marR="91440" marT="54864" marB="54864" anchor="t">
+                  <a:tcPr marL="73152" marR="73152" marT="27432" marB="27432" anchor="ctr">
                     <a:lnL w="9525" cap="flat" cmpd="sng" algn="ctr">
                       <a:solidFill>
                         <a:srgbClr val="D5DBE2"/>
@@ -2935,17 +2325,17 @@
                         <a:buNone/>
                       </a:pPr>
                       <a:r>
-                        <a:rPr lang="en-US" sz="1200" dirty="0">
+                        <a:rPr lang="en-US" sz="950" dirty="0">
                           <a:solidFill>
                             <a:schemeClr val="tx1"/>
                           </a:solidFill>
                         </a:rPr>
                         <a:t>Po rozmowach partner nie kontynuuje współpracy.</a:t>
                       </a:r>
-                      <a:endParaRPr lang="en-US" sz="1200" dirty="0"/>
+                      <a:endParaRPr lang="en-US" sz="950" dirty="0"/>
                     </a:p>
                   </a:txBody>
-                  <a:tcPr marL="91440" marR="91440" marT="54864" marB="54864" anchor="t">
+                  <a:tcPr marL="73152" marR="73152" marT="27432" marB="27432" anchor="ctr">
                     <a:lnL w="9525" cap="flat" cmpd="sng" algn="ctr">
                       <a:solidFill>
                         <a:srgbClr val="D5DBE2"/>
@@ -2992,18 +2382,10 @@
                       <a:pPr indent="0" marL="0">
                         <a:buNone/>
                       </a:pPr>
-                      <a:r>
-                        <a:rPr lang="en-US" sz="1200" dirty="0">
-                          <a:solidFill>
-                            <a:schemeClr val="accent3"/>
-                          </a:solidFill>
-                        </a:rPr>
-                        <a:t>–</a:t>
-                      </a:r>
-                      <a:endParaRPr lang="en-US" sz="1200" dirty="0"/>
+                      <a:endParaRPr lang="en-US" sz="950" dirty="0"/>
                     </a:p>
                   </a:txBody>
-                  <a:tcPr marL="91440" marR="91440" marT="54864" marB="54864" anchor="t">
+                  <a:tcPr marL="73152" marR="73152" marT="27432" marB="27432" anchor="ctr">
                     <a:lnL w="9525" cap="flat" cmpd="sng" algn="ctr">
                       <a:solidFill>
                         <a:srgbClr val="D5DBE2"/>
@@ -3056,17 +2438,17 @@
                         <a:buNone/>
                       </a:pPr>
                       <a:r>
-                        <a:rPr lang="en-US" sz="1300" b="1" dirty="0">
+                        <a:rPr lang="en-US" sz="950" b="1" dirty="0">
                           <a:solidFill>
                             <a:schemeClr val="tx1"/>
                           </a:solidFill>
                         </a:rPr>
                         <a:t>OLX</a:t>
                       </a:r>
-                      <a:endParaRPr lang="en-US" sz="1300" dirty="0"/>
+                      <a:endParaRPr lang="en-US" sz="950" dirty="0"/>
                     </a:p>
                   </a:txBody>
-                  <a:tcPr marL="91440" marR="91440" marT="54864" marB="54864" anchor="t">
+                  <a:tcPr marL="73152" marR="73152" marT="27432" marB="27432" anchor="ctr">
                     <a:lnL w="9525" cap="flat" cmpd="sng" algn="ctr">
                       <a:solidFill>
                         <a:srgbClr val="D5DBE2"/>
@@ -3114,17 +2496,17 @@
                         <a:buNone/>
                       </a:pPr>
                       <a:r>
-                        <a:rPr lang="en-US" sz="1200" dirty="0">
+                        <a:rPr lang="en-US" sz="950" dirty="0">
                           <a:solidFill>
                             <a:schemeClr val="tx1"/>
                           </a:solidFill>
                         </a:rPr>
                         <a:t>Spotkanie zaplanowane na 12.10.2026.</a:t>
                       </a:r>
-                      <a:endParaRPr lang="en-US" sz="1200" dirty="0"/>
+                      <a:endParaRPr lang="en-US" sz="950" dirty="0"/>
                     </a:p>
                   </a:txBody>
-                  <a:tcPr marL="91440" marR="91440" marT="54864" marB="54864" anchor="t">
+                  <a:tcPr marL="73152" marR="73152" marT="27432" marB="27432" anchor="ctr">
                     <a:lnL w="9525" cap="flat" cmpd="sng" algn="ctr">
                       <a:solidFill>
                         <a:srgbClr val="D5DBE2"/>
@@ -3171,18 +2553,10 @@
                       <a:pPr indent="0" marL="0">
                         <a:buNone/>
                       </a:pPr>
-                      <a:r>
-                        <a:rPr lang="en-US" sz="1200" dirty="0">
-                          <a:solidFill>
-                            <a:schemeClr val="accent3"/>
-                          </a:solidFill>
-                        </a:rPr>
-                        <a:t>–</a:t>
-                      </a:r>
-                      <a:endParaRPr lang="en-US" sz="1200" dirty="0"/>
+                      <a:endParaRPr lang="en-US" sz="950" dirty="0"/>
                     </a:p>
                   </a:txBody>
-                  <a:tcPr marL="91440" marR="91440" marT="54864" marB="54864" anchor="t">
+                  <a:tcPr marL="73152" marR="73152" marT="27432" marB="27432" anchor="ctr">
                     <a:lnL w="9525" cap="flat" cmpd="sng" algn="ctr">
                       <a:solidFill>
                         <a:srgbClr val="D5DBE2"/>
@@ -3225,147 +2599,8 @@
                   </a:tcPr>
                 </a:tc>
               </a:tr>
-            </a:tbl>
-          </a:graphicData>
-        </a:graphic>
-      </p:graphicFrame>
-      <p:sp>
-        <p:nvSpPr>
-          <p:cNvPr id="25" name="Slide Number Placeholder 0"/>
-          <p:cNvSpPr>
-            <a:spLocks noGrp="1"/>
-          </p:cNvSpPr>
-          <p:nvPr>
-            <p:ph type="sldNum" sz="quarter" idx="4294967295"/>
-          </p:nvPr>
-        </p:nvSpPr>
-        <p:spPr>
-          <a:xfrm>
-            <a:off x="8321040" y="4828032"/>
-            <a:ext cx="365760" cy="182880"/>
-          </a:xfrm>
-          <a:prstGeom prst="rect">
-            <a:avLst/>
-          </a:prstGeom>
-          <a:extLst>
-            <a:ext uri="{C572A759-6A51-4108-AA02-DFA0A04FC94B}">
-              <ma14:wrappingTextBoxFlag xmlns:ma14="http://schemas.microsoft.com/office/mac/drawingml/2011/main" val="0"/>
-            </a:ext>
-          </a:extLst>
-        </p:spPr>
-        <p:txBody>
-          <a:bodyPr/>
-          <a:lstStyle>
-            <a:lvl1pPr>
-              <a:defRPr sz="900">
-                <a:solidFill>
-                  <a:schemeClr val="accent3"/>
-                </a:solidFill>
-              </a:defRPr>
-            </a:lvl1pPr>
-          </a:lstStyle>
-          <a:p>
-            <a:pPr algn="r"/>
-            <a:fld id="{F7021451-1387-4CA6-816F-3879F97B5CBC}" type="slidenum">
-              <a:rPr b="0" lang="en-US"/>
-              <a:t>2</a:t>
-            </a:fld>
-            <a:endParaRPr lang="en-US"/>
-          </a:p>
-        </p:txBody>
-      </p:sp>
-    </p:spTree>
-  </p:cSld>
-  <p:clrMapOvr>
-    <a:masterClrMapping/>
-  </p:clrMapOvr>
-</p:sld>
-</file>
-
-<file path=ppt/slides/slide3.xml><?xml version="1.0" encoding="utf-8"?>
-<p:sld xmlns:a="http://schemas.openxmlformats.org/drawingml/2006/main" xmlns:r="http://schemas.openxmlformats.org/officeDocument/2006/relationships" xmlns:p="http://schemas.openxmlformats.org/presentationml/2006/main">
-  <p:cSld name="Slide 3">
-    <p:spTree>
-      <p:nvGrpSpPr>
-        <p:cNvPr id="1" name=""/>
-        <p:cNvGrpSpPr/>
-        <p:nvPr/>
-      </p:nvGrpSpPr>
-      <p:grpSpPr>
-        <a:xfrm>
-          <a:off x="0" y="0"/>
-          <a:ext cx="0" cy="0"/>
-          <a:chOff x="0" y="0"/>
-          <a:chExt cx="0" cy="0"/>
-        </a:xfrm>
-      </p:grpSpPr>
-      <p:sp>
-        <p:nvSpPr>
-          <p:cNvPr id="2" name="Text 1"/>
-          <p:cNvSpPr/>
-          <p:nvPr>
-            <p:ph idx="101" type="title" hasCustomPrompt="1"/>
-          </p:nvPr>
-        </p:nvSpPr>
-        <p:spPr>
-          <a:xfrm>
-            <a:off x="457200" y="502920"/>
-            <a:ext cx="8229600" cy="457200"/>
-          </a:xfrm>
-          <a:prstGeom prst="rect">
-            <a:avLst/>
-          </a:prstGeom>
-          <a:noFill/>
-          <a:ln/>
-        </p:spPr>
-        <p:txBody>
-          <a:bodyPr wrap="square" lIns="0" tIns="0" rIns="0" bIns="0" rtlCol="0" anchor="t"/>
-          <a:lstStyle/>
-          <a:p>
-            <a:pPr algn="l" indent="0" marL="0">
-              <a:buNone/>
-            </a:pPr>
-            <a:r>
-              <a:rPr lang="en-US" sz="2600" b="1" dirty="0">
-                <a:solidFill>
-                  <a:schemeClr val="accent1"/>
-                </a:solidFill>
-              </a:rPr>
-              <a:t>Technologia i strategia</a:t>
-            </a:r>
-            <a:endParaRPr lang="en-US" sz="2600" dirty="0"/>
-          </a:p>
-        </p:txBody>
-      </p:sp>
-      <p:graphicFrame>
-        <p:nvGraphicFramePr>
-          <p:cNvPr id="4" name="Tabela statusu"/>
-          <p:cNvGraphicFramePr>
-            <a:graphicFrameLocks noGrp="1"/>
-          </p:cNvGraphicFramePr>
-          <p:nvPr>
-            <p:extLst>
-              <p:ext uri="{D42A27DB-BD31-4B8C-83A1-F6EECF244321}">
-                <p14:modId xmlns:p14="http://schemas.microsoft.com/office/powerpoint/2010/main" val="1579011935"/>
-              </p:ext>
-            </p:extLst>
-          </p:nvPr>
-        </p:nvGraphicFramePr>
-        <p:xfrm>
-          <a:off x="457200" y="1188720"/>
-          <a:ext cx="8229600" cy="914400"/>
-        </p:xfrm>
-        <a:graphic>
-          <a:graphicData uri="http://schemas.openxmlformats.org/drawingml/2006/table">
-            <a:tbl>
-              <a:tblPr/>
-              <a:tblGrid>
-                <a:gridCol w="1554480"/>
-                <a:gridCol w="4023360"/>
-                <a:gridCol w="2651760"/>
-              </a:tblGrid>
               <a:tr h="0">
-                <a:tc>
+                <a:tc gridSpan="3">
                   <a:txBody>
                     <a:bodyPr/>
                     <a:lstStyle/>
@@ -3374,17 +2609,17 @@
                         <a:buNone/>
                       </a:pPr>
                       <a:r>
-                        <a:rPr lang="en-US" sz="1200" b="1" dirty="0">
+                        <a:rPr lang="en-US" sz="850" b="1" spc="100" kern="0" dirty="0">
                           <a:solidFill>
-                            <a:schemeClr val="bg1"/>
+                            <a:schemeClr val="accent1"/>
                           </a:solidFill>
                         </a:rPr>
-                        <a:t>Podmiot</a:t>
+                        <a:t>TECHNOLOGIA</a:t>
                       </a:r>
-                      <a:endParaRPr lang="en-US" sz="1200" dirty="0"/>
+                      <a:endParaRPr lang="en-US" sz="850" dirty="0"/>
                     </a:p>
                   </a:txBody>
-                  <a:tcPr marL="91440" marR="91440" marT="54864" marB="54864" anchor="ctr">
+                  <a:tcPr marL="73152" marR="73152" marT="27432" marB="27432" anchor="ctr">
                     <a:lnL w="9525" cap="flat" cmpd="sng" algn="ctr">
                       <a:solidFill>
                         <a:srgbClr val="D5DBE2"/>
@@ -3422,131 +2657,15 @@
                       <a:tailEnd type="none" w="med" len="med"/>
                     </a:lnB>
                     <a:solidFill>
-                      <a:schemeClr val="accent1"/>
+                      <a:schemeClr val="bg2"/>
                     </a:solidFill>
                   </a:tcPr>
                 </a:tc>
-                <a:tc>
-                  <a:txBody>
-                    <a:bodyPr/>
-                    <a:lstStyle/>
-                    <a:p>
-                      <a:pPr indent="0" marL="0">
-                        <a:buNone/>
-                      </a:pPr>
-                      <a:r>
-                        <a:rPr lang="en-US" sz="1200" b="1" dirty="0">
-                          <a:solidFill>
-                            <a:schemeClr val="bg1"/>
-                          </a:solidFill>
-                        </a:rPr>
-                        <a:t>Etap</a:t>
-                      </a:r>
-                      <a:endParaRPr lang="en-US" sz="1200" dirty="0"/>
-                    </a:p>
-                  </a:txBody>
-                  <a:tcPr marL="91440" marR="91440" marT="54864" marB="54864" anchor="ctr">
-                    <a:lnL w="9525" cap="flat" cmpd="sng" algn="ctr">
-                      <a:solidFill>
-                        <a:srgbClr val="D5DBE2"/>
-                      </a:solidFill>
-                      <a:prstDash val="solid"/>
-                      <a:round/>
-                      <a:headEnd type="none" w="med" len="med"/>
-                      <a:tailEnd type="none" w="med" len="med"/>
-                    </a:lnL>
-                    <a:lnR w="9525" cap="flat" cmpd="sng" algn="ctr">
-                      <a:solidFill>
-                        <a:srgbClr val="D5DBE2"/>
-                      </a:solidFill>
-                      <a:prstDash val="solid"/>
-                      <a:round/>
-                      <a:headEnd type="none" w="med" len="med"/>
-                      <a:tailEnd type="none" w="med" len="med"/>
-                    </a:lnR>
-                    <a:lnT w="9525" cap="flat" cmpd="sng" algn="ctr">
-                      <a:solidFill>
-                        <a:srgbClr val="D5DBE2"/>
-                      </a:solidFill>
-                      <a:prstDash val="solid"/>
-                      <a:round/>
-                      <a:headEnd type="none" w="med" len="med"/>
-                      <a:tailEnd type="none" w="med" len="med"/>
-                    </a:lnT>
-                    <a:lnB w="9525" cap="flat" cmpd="sng" algn="ctr">
-                      <a:solidFill>
-                        <a:srgbClr val="D5DBE2"/>
-                      </a:solidFill>
-                      <a:prstDash val="solid"/>
-                      <a:round/>
-                      <a:headEnd type="none" w="med" len="med"/>
-                      <a:tailEnd type="none" w="med" len="med"/>
-                    </a:lnB>
-                    <a:solidFill>
-                      <a:schemeClr val="accent1"/>
-                    </a:solidFill>
-                  </a:tcPr>
-                </a:tc>
-                <a:tc>
-                  <a:txBody>
-                    <a:bodyPr/>
-                    <a:lstStyle/>
-                    <a:p>
-                      <a:pPr indent="0" marL="0">
-                        <a:buNone/>
-                      </a:pPr>
-                      <a:r>
-                        <a:rPr lang="en-US" sz="1200" b="1" dirty="0">
-                          <a:solidFill>
-                            <a:schemeClr val="bg1"/>
-                          </a:solidFill>
-                        </a:rPr>
-                        <a:t>Do dyskusji</a:t>
-                      </a:r>
-                      <a:endParaRPr lang="en-US" sz="1200" dirty="0"/>
-                    </a:p>
-                  </a:txBody>
-                  <a:tcPr marL="91440" marR="91440" marT="54864" marB="54864" anchor="ctr">
-                    <a:lnL w="9525" cap="flat" cmpd="sng" algn="ctr">
-                      <a:solidFill>
-                        <a:srgbClr val="D5DBE2"/>
-                      </a:solidFill>
-                      <a:prstDash val="solid"/>
-                      <a:round/>
-                      <a:headEnd type="none" w="med" len="med"/>
-                      <a:tailEnd type="none" w="med" len="med"/>
-                    </a:lnL>
-                    <a:lnR w="9525" cap="flat" cmpd="sng" algn="ctr">
-                      <a:solidFill>
-                        <a:srgbClr val="D5DBE2"/>
-                      </a:solidFill>
-                      <a:prstDash val="solid"/>
-                      <a:round/>
-                      <a:headEnd type="none" w="med" len="med"/>
-                      <a:tailEnd type="none" w="med" len="med"/>
-                    </a:lnR>
-                    <a:lnT w="9525" cap="flat" cmpd="sng" algn="ctr">
-                      <a:solidFill>
-                        <a:srgbClr val="D5DBE2"/>
-                      </a:solidFill>
-                      <a:prstDash val="solid"/>
-                      <a:round/>
-                      <a:headEnd type="none" w="med" len="med"/>
-                      <a:tailEnd type="none" w="med" len="med"/>
-                    </a:lnT>
-                    <a:lnB w="9525" cap="flat" cmpd="sng" algn="ctr">
-                      <a:solidFill>
-                        <a:srgbClr val="D5DBE2"/>
-                      </a:solidFill>
-                      <a:prstDash val="solid"/>
-                      <a:round/>
-                      <a:headEnd type="none" w="med" len="med"/>
-                      <a:tailEnd type="none" w="med" len="med"/>
-                    </a:lnB>
-                    <a:solidFill>
-                      <a:schemeClr val="accent2"/>
-                    </a:solidFill>
-                  </a:tcPr>
+                <a:tc hMerge="1">
+                  <a:tcPr/>
+                </a:tc>
+                <a:tc hMerge="1">
+                  <a:tcPr/>
                 </a:tc>
               </a:tr>
               <a:tr h="0">
@@ -3559,17 +2678,17 @@
                         <a:buNone/>
                       </a:pPr>
                       <a:r>
-                        <a:rPr lang="en-US" sz="1400" b="1" dirty="0">
+                        <a:rPr lang="en-US" sz="950" b="1" dirty="0">
                           <a:solidFill>
                             <a:schemeClr val="tx1"/>
                           </a:solidFill>
                         </a:rPr>
                         <a:t>Farmster</a:t>
                       </a:r>
-                      <a:endParaRPr lang="en-US" sz="1400" dirty="0"/>
+                      <a:endParaRPr lang="en-US" sz="950" dirty="0"/>
                     </a:p>
                   </a:txBody>
-                  <a:tcPr marL="91440" marR="91440" marT="54864" marB="54864" anchor="t">
+                  <a:tcPr marL="73152" marR="73152" marT="27432" marB="27432" anchor="ctr">
                     <a:lnL w="9525" cap="flat" cmpd="sng" algn="ctr">
                       <a:solidFill>
                         <a:srgbClr val="D5DBE2"/>
@@ -3617,17 +2736,17 @@
                         <a:buNone/>
                       </a:pPr>
                       <a:r>
-                        <a:rPr lang="en-US" sz="1300" dirty="0">
+                        <a:rPr lang="en-US" sz="950" dirty="0">
                           <a:solidFill>
                             <a:schemeClr val="tx1"/>
                           </a:solidFill>
                         </a:rPr>
-                        <a:t>Razem z p. Pawłem Bizuńskim analizujemy umowę pod kątem możliwości wykorzystania funkcjonalności Farmstera w GAia. Po zgodzie działu prawnego planujemy z Działem IT pobranie kodu źródłowego Farmstera z naszej chmury Azure i jego audyt.</a:t>
+                        <a:t>Razem z p. Pawłem Bizuńskim analizujemy umowę pod kątem wykorzystania funkcjonalności Farmstera w GAia. Po zgodzie działu prawnego planujemy z Działem IT pobranie kodu źródłowego z naszej chmury Azure i jego audyt.</a:t>
                       </a:r>
-                      <a:endParaRPr lang="en-US" sz="1300" dirty="0"/>
+                      <a:endParaRPr lang="en-US" sz="950" dirty="0"/>
                     </a:p>
                   </a:txBody>
-                  <a:tcPr marL="91440" marR="91440" marT="54864" marB="54864" anchor="t">
+                  <a:tcPr marL="73152" marR="73152" marT="27432" marB="27432" anchor="ctr">
                     <a:lnL w="9525" cap="flat" cmpd="sng" algn="ctr">
                       <a:solidFill>
                         <a:srgbClr val="D5DBE2"/>
@@ -3675,17 +2794,17 @@
                         <a:buNone/>
                       </a:pPr>
                       <a:r>
-                        <a:rPr lang="en-US" sz="1300" b="1" dirty="0">
+                        <a:rPr lang="en-US" sz="950" b="1" dirty="0">
                           <a:solidFill>
                             <a:schemeClr val="accent2"/>
                           </a:solidFill>
                         </a:rPr>
                         <a:t>Czy rozpatrujemy wykupienie AgriSolutions, dostawcy Farmstera?</a:t>
                       </a:r>
-                      <a:endParaRPr lang="en-US" sz="1300" dirty="0"/>
+                      <a:endParaRPr lang="en-US" sz="950" dirty="0"/>
                     </a:p>
                   </a:txBody>
-                  <a:tcPr marL="91440" marR="91440" marT="54864" marB="54864" anchor="t">
+                  <a:tcPr marL="73152" marR="73152" marT="27432" marB="27432" anchor="ctr">
                     <a:lnL w="9525" cap="flat" cmpd="sng" algn="ctr">
                       <a:solidFill>
                         <a:srgbClr val="D5DBE2"/>
@@ -3726,6 +2845,75 @@
                       <a:srgbClr val="FBF1F1"/>
                     </a:solidFill>
                   </a:tcPr>
+                </a:tc>
+              </a:tr>
+              <a:tr h="0">
+                <a:tc gridSpan="3">
+                  <a:txBody>
+                    <a:bodyPr/>
+                    <a:lstStyle/>
+                    <a:p>
+                      <a:pPr indent="0" marL="0">
+                        <a:buNone/>
+                      </a:pPr>
+                      <a:r>
+                        <a:rPr lang="en-US" sz="850" b="1" spc="100" kern="0" dirty="0">
+                          <a:solidFill>
+                            <a:schemeClr val="accent1"/>
+                          </a:solidFill>
+                        </a:rPr>
+                        <a:t>STRATEGIA</a:t>
+                      </a:r>
+                      <a:endParaRPr lang="en-US" sz="850" dirty="0"/>
+                    </a:p>
+                  </a:txBody>
+                  <a:tcPr marL="73152" marR="73152" marT="27432" marB="27432" anchor="ctr">
+                    <a:lnL w="9525" cap="flat" cmpd="sng" algn="ctr">
+                      <a:solidFill>
+                        <a:srgbClr val="D5DBE2"/>
+                      </a:solidFill>
+                      <a:prstDash val="solid"/>
+                      <a:round/>
+                      <a:headEnd type="none" w="med" len="med"/>
+                      <a:tailEnd type="none" w="med" len="med"/>
+                    </a:lnL>
+                    <a:lnR w="9525" cap="flat" cmpd="sng" algn="ctr">
+                      <a:solidFill>
+                        <a:srgbClr val="D5DBE2"/>
+                      </a:solidFill>
+                      <a:prstDash val="solid"/>
+                      <a:round/>
+                      <a:headEnd type="none" w="med" len="med"/>
+                      <a:tailEnd type="none" w="med" len="med"/>
+                    </a:lnR>
+                    <a:lnT w="9525" cap="flat" cmpd="sng" algn="ctr">
+                      <a:solidFill>
+                        <a:srgbClr val="D5DBE2"/>
+                      </a:solidFill>
+                      <a:prstDash val="solid"/>
+                      <a:round/>
+                      <a:headEnd type="none" w="med" len="med"/>
+                      <a:tailEnd type="none" w="med" len="med"/>
+                    </a:lnT>
+                    <a:lnB w="9525" cap="flat" cmpd="sng" algn="ctr">
+                      <a:solidFill>
+                        <a:srgbClr val="D5DBE2"/>
+                      </a:solidFill>
+                      <a:prstDash val="solid"/>
+                      <a:round/>
+                      <a:headEnd type="none" w="med" len="med"/>
+                      <a:tailEnd type="none" w="med" len="med"/>
+                    </a:lnB>
+                    <a:solidFill>
+                      <a:schemeClr val="bg2"/>
+                    </a:solidFill>
+                  </a:tcPr>
+                </a:tc>
+                <a:tc hMerge="1">
+                  <a:tcPr/>
+                </a:tc>
+                <a:tc hMerge="1">
+                  <a:tcPr/>
                 </a:tc>
               </a:tr>
               <a:tr h="0">
@@ -3738,17 +2926,17 @@
                         <a:buNone/>
                       </a:pPr>
                       <a:r>
-                        <a:rPr lang="en-US" sz="1400" b="1" dirty="0">
+                        <a:rPr lang="en-US" sz="950" b="1" dirty="0">
                           <a:solidFill>
                             <a:schemeClr val="tx1"/>
                           </a:solidFill>
                         </a:rPr>
                         <a:t>Strategia nawozowa</a:t>
                       </a:r>
-                      <a:endParaRPr lang="en-US" sz="1400" dirty="0"/>
+                      <a:endParaRPr lang="en-US" sz="950" dirty="0"/>
                     </a:p>
                   </a:txBody>
-                  <a:tcPr marL="91440" marR="91440" marT="54864" marB="54864" anchor="t">
+                  <a:tcPr marL="73152" marR="73152" marT="27432" marB="27432" anchor="ctr">
                     <a:lnL w="9525" cap="flat" cmpd="sng" algn="ctr">
                       <a:solidFill>
                         <a:srgbClr val="D5DBE2"/>
@@ -3796,17 +2984,17 @@
                         <a:buNone/>
                       </a:pPr>
                       <a:r>
-                        <a:rPr lang="en-US" sz="1300" dirty="0">
+                        <a:rPr lang="en-US" sz="950" dirty="0">
                           <a:solidFill>
                             <a:schemeClr val="tx1"/>
                           </a:solidFill>
                         </a:rPr>
                         <a:t>GAia została włączona do strategii nawozowej. Obszar będzie omawiany z Wiceprezesem Piotrem Szajczykiem.</a:t>
                       </a:r>
-                      <a:endParaRPr lang="en-US" sz="1300" dirty="0"/>
+                      <a:endParaRPr lang="en-US" sz="950" dirty="0"/>
                     </a:p>
                   </a:txBody>
-                  <a:tcPr marL="91440" marR="91440" marT="54864" marB="54864" anchor="t">
+                  <a:tcPr marL="73152" marR="73152" marT="27432" marB="27432" anchor="ctr">
                     <a:lnL w="9525" cap="flat" cmpd="sng" algn="ctr">
                       <a:solidFill>
                         <a:srgbClr val="D5DBE2"/>
@@ -3854,17 +3042,17 @@
                         <a:buNone/>
                       </a:pPr>
                       <a:r>
-                        <a:rPr lang="en-US" sz="1300" b="1" dirty="0">
+                        <a:rPr lang="en-US" sz="950" b="1" dirty="0">
                           <a:solidFill>
                             <a:schemeClr val="accent2"/>
                           </a:solidFill>
                         </a:rPr>
                         <a:t>Czy dołączamy GAię do innych strategii budowanych aktualnie w Grupie?</a:t>
                       </a:r>
-                      <a:endParaRPr lang="en-US" sz="1300" dirty="0"/>
+                      <a:endParaRPr lang="en-US" sz="950" dirty="0"/>
                     </a:p>
                   </a:txBody>
-                  <a:tcPr marL="91440" marR="91440" marT="54864" marB="54864" anchor="t">
+                  <a:tcPr marL="73152" marR="73152" marT="27432" marB="27432" anchor="ctr">
                     <a:lnL w="9525" cap="flat" cmpd="sng" algn="ctr">
                       <a:solidFill>
                         <a:srgbClr val="D5DBE2"/>
@@ -3911,1099 +3099,6 @@
           </a:graphicData>
         </a:graphic>
       </p:graphicFrame>
-      <p:sp>
-        <p:nvSpPr>
-          <p:cNvPr id="25" name="Slide Number Placeholder 0"/>
-          <p:cNvSpPr>
-            <a:spLocks noGrp="1"/>
-          </p:cNvSpPr>
-          <p:nvPr>
-            <p:ph type="sldNum" sz="quarter" idx="4294967295"/>
-          </p:nvPr>
-        </p:nvSpPr>
-        <p:spPr>
-          <a:xfrm>
-            <a:off x="8321040" y="4828032"/>
-            <a:ext cx="365760" cy="182880"/>
-          </a:xfrm>
-          <a:prstGeom prst="rect">
-            <a:avLst/>
-          </a:prstGeom>
-          <a:extLst>
-            <a:ext uri="{C572A759-6A51-4108-AA02-DFA0A04FC94B}">
-              <ma14:wrappingTextBoxFlag xmlns:ma14="http://schemas.microsoft.com/office/mac/drawingml/2011/main" val="0"/>
-            </a:ext>
-          </a:extLst>
-        </p:spPr>
-        <p:txBody>
-          <a:bodyPr/>
-          <a:lstStyle>
-            <a:lvl1pPr>
-              <a:defRPr sz="900">
-                <a:solidFill>
-                  <a:schemeClr val="accent3"/>
-                </a:solidFill>
-              </a:defRPr>
-            </a:lvl1pPr>
-          </a:lstStyle>
-          <a:p>
-            <a:pPr algn="r"/>
-            <a:fld id="{F7021451-1387-4CA6-816F-3879F97B5CBC}" type="slidenum">
-              <a:rPr b="0" lang="en-US"/>
-              <a:t>3</a:t>
-            </a:fld>
-            <a:endParaRPr lang="en-US"/>
-          </a:p>
-        </p:txBody>
-      </p:sp>
-    </p:spTree>
-  </p:cSld>
-  <p:clrMapOvr>
-    <a:masterClrMapping/>
-  </p:clrMapOvr>
-</p:sld>
-</file>
-
-<file path=ppt/slides/slide4.xml><?xml version="1.0" encoding="utf-8"?>
-<p:sld xmlns:a="http://schemas.openxmlformats.org/drawingml/2006/main" xmlns:r="http://schemas.openxmlformats.org/officeDocument/2006/relationships" xmlns:p="http://schemas.openxmlformats.org/presentationml/2006/main">
-  <p:cSld name="Slide 4">
-    <p:spTree>
-      <p:nvGrpSpPr>
-        <p:cNvPr id="1" name=""/>
-        <p:cNvGrpSpPr/>
-        <p:nvPr/>
-      </p:nvGrpSpPr>
-      <p:grpSpPr>
-        <a:xfrm>
-          <a:off x="0" y="0"/>
-          <a:ext cx="0" cy="0"/>
-          <a:chOff x="0" y="0"/>
-          <a:chExt cx="0" cy="0"/>
-        </a:xfrm>
-      </p:grpSpPr>
-      <p:sp>
-        <p:nvSpPr>
-          <p:cNvPr id="2" name="Text 1"/>
-          <p:cNvSpPr/>
-          <p:nvPr>
-            <p:ph idx="101" type="title" hasCustomPrompt="1"/>
-          </p:nvPr>
-        </p:nvSpPr>
-        <p:spPr>
-          <a:xfrm>
-            <a:off x="457200" y="502920"/>
-            <a:ext cx="8229600" cy="457200"/>
-          </a:xfrm>
-          <a:prstGeom prst="rect">
-            <a:avLst/>
-          </a:prstGeom>
-          <a:noFill/>
-          <a:ln/>
-        </p:spPr>
-        <p:txBody>
-          <a:bodyPr wrap="square" lIns="0" tIns="0" rIns="0" bIns="0" rtlCol="0" anchor="t"/>
-          <a:lstStyle/>
-          <a:p>
-            <a:pPr algn="l" indent="0" marL="0">
-              <a:buNone/>
-            </a:pPr>
-            <a:r>
-              <a:rPr lang="en-US" sz="2600" b="1" dirty="0">
-                <a:solidFill>
-                  <a:schemeClr val="accent1"/>
-                </a:solidFill>
-              </a:rPr>
-              <a:t>Do dyskusji: prosimy o odpowiedź</a:t>
-            </a:r>
-            <a:endParaRPr lang="en-US" sz="2600" dirty="0"/>
-          </a:p>
-        </p:txBody>
-      </p:sp>
-      <p:graphicFrame>
-        <p:nvGraphicFramePr>
-          <p:cNvPr id="5" name="Pytania do dyskusji"/>
-          <p:cNvGraphicFramePr>
-            <a:graphicFrameLocks noGrp="1"/>
-          </p:cNvGraphicFramePr>
-          <p:nvPr>
-            <p:extLst>
-              <p:ext uri="{D42A27DB-BD31-4B8C-83A1-F6EECF244321}">
-                <p14:modId xmlns:p14="http://schemas.microsoft.com/office/powerpoint/2010/main" val="1579011935"/>
-              </p:ext>
-            </p:extLst>
-          </p:nvPr>
-        </p:nvGraphicFramePr>
-        <p:xfrm>
-          <a:off x="457200" y="1234440"/>
-          <a:ext cx="8229600" cy="914400"/>
-        </p:xfrm>
-        <a:graphic>
-          <a:graphicData uri="http://schemas.openxmlformats.org/drawingml/2006/table">
-            <a:tbl>
-              <a:tblPr/>
-              <a:tblGrid>
-                <a:gridCol w="457200"/>
-                <a:gridCol w="1371600"/>
-                <a:gridCol w="6400800"/>
-              </a:tblGrid>
-              <a:tr h="603504">
-                <a:tc>
-                  <a:txBody>
-                    <a:bodyPr/>
-                    <a:lstStyle/>
-                    <a:p>
-                      <a:pPr algn="ctr" indent="0" marL="0">
-                        <a:buNone/>
-                      </a:pPr>
-                      <a:r>
-                        <a:rPr lang="en-US" sz="1400" b="1" dirty="0">
-                          <a:solidFill>
-                            <a:schemeClr val="bg1"/>
-                          </a:solidFill>
-                        </a:rPr>
-                        <a:t>1</a:t>
-                      </a:r>
-                      <a:endParaRPr lang="en-US" sz="1400" dirty="0"/>
-                    </a:p>
-                  </a:txBody>
-                  <a:tcPr marL="109728" marR="109728" marT="45720" marB="45720" anchor="ctr">
-                    <a:lnL w="9525" cap="flat" cmpd="sng" algn="ctr">
-                      <a:solidFill>
-                        <a:srgbClr val="D5DBE2"/>
-                      </a:solidFill>
-                      <a:prstDash val="solid"/>
-                      <a:round/>
-                      <a:headEnd type="none" w="med" len="med"/>
-                      <a:tailEnd type="none" w="med" len="med"/>
-                    </a:lnL>
-                    <a:lnR w="9525" cap="flat" cmpd="sng" algn="ctr">
-                      <a:solidFill>
-                        <a:srgbClr val="D5DBE2"/>
-                      </a:solidFill>
-                      <a:prstDash val="solid"/>
-                      <a:round/>
-                      <a:headEnd type="none" w="med" len="med"/>
-                      <a:tailEnd type="none" w="med" len="med"/>
-                    </a:lnR>
-                    <a:lnT w="9525" cap="flat" cmpd="sng" algn="ctr">
-                      <a:solidFill>
-                        <a:srgbClr val="D5DBE2"/>
-                      </a:solidFill>
-                      <a:prstDash val="solid"/>
-                      <a:round/>
-                      <a:headEnd type="none" w="med" len="med"/>
-                      <a:tailEnd type="none" w="med" len="med"/>
-                    </a:lnT>
-                    <a:lnB w="9525" cap="flat" cmpd="sng" algn="ctr">
-                      <a:solidFill>
-                        <a:srgbClr val="D5DBE2"/>
-                      </a:solidFill>
-                      <a:prstDash val="solid"/>
-                      <a:round/>
-                      <a:headEnd type="none" w="med" len="med"/>
-                      <a:tailEnd type="none" w="med" len="med"/>
-                    </a:lnB>
-                    <a:solidFill>
-                      <a:schemeClr val="accent2"/>
-                    </a:solidFill>
-                  </a:tcPr>
-                </a:tc>
-                <a:tc>
-                  <a:txBody>
-                    <a:bodyPr/>
-                    <a:lstStyle/>
-                    <a:p>
-                      <a:pPr indent="0" marL="0">
-                        <a:buNone/>
-                      </a:pPr>
-                      <a:r>
-                        <a:rPr lang="en-US" sz="1300" b="1" dirty="0">
-                          <a:solidFill>
-                            <a:schemeClr val="accent1"/>
-                          </a:solidFill>
-                        </a:rPr>
-                        <a:t>ARiMR</a:t>
-                      </a:r>
-                      <a:endParaRPr lang="en-US" sz="1300" dirty="0"/>
-                    </a:p>
-                  </a:txBody>
-                  <a:tcPr marL="109728" marR="109728" marT="45720" marB="45720" anchor="ctr">
-                    <a:lnL w="9525" cap="flat" cmpd="sng" algn="ctr">
-                      <a:solidFill>
-                        <a:srgbClr val="D5DBE2"/>
-                      </a:solidFill>
-                      <a:prstDash val="solid"/>
-                      <a:round/>
-                      <a:headEnd type="none" w="med" len="med"/>
-                      <a:tailEnd type="none" w="med" len="med"/>
-                    </a:lnL>
-                    <a:lnR w="9525" cap="flat" cmpd="sng" algn="ctr">
-                      <a:solidFill>
-                        <a:srgbClr val="D5DBE2"/>
-                      </a:solidFill>
-                      <a:prstDash val="solid"/>
-                      <a:round/>
-                      <a:headEnd type="none" w="med" len="med"/>
-                      <a:tailEnd type="none" w="med" len="med"/>
-                    </a:lnR>
-                    <a:lnT w="9525" cap="flat" cmpd="sng" algn="ctr">
-                      <a:solidFill>
-                        <a:srgbClr val="D5DBE2"/>
-                      </a:solidFill>
-                      <a:prstDash val="solid"/>
-                      <a:round/>
-                      <a:headEnd type="none" w="med" len="med"/>
-                      <a:tailEnd type="none" w="med" len="med"/>
-                    </a:lnT>
-                    <a:lnB w="9525" cap="flat" cmpd="sng" algn="ctr">
-                      <a:solidFill>
-                        <a:srgbClr val="D5DBE2"/>
-                      </a:solidFill>
-                      <a:prstDash val="solid"/>
-                      <a:round/>
-                      <a:headEnd type="none" w="med" len="med"/>
-                      <a:tailEnd type="none" w="med" len="med"/>
-                    </a:lnB>
-                  </a:tcPr>
-                </a:tc>
-                <a:tc>
-                  <a:txBody>
-                    <a:bodyPr/>
-                    <a:lstStyle/>
-                    <a:p>
-                      <a:pPr indent="0" marL="0">
-                        <a:buNone/>
-                      </a:pPr>
-                      <a:r>
-                        <a:rPr lang="en-US" sz="1300" dirty="0">
-                          <a:solidFill>
-                            <a:schemeClr val="tx1"/>
-                          </a:solidFill>
-                        </a:rPr>
-                        <a:t>Na co możemy się zgodzić we współpracy z ARiMR przy budowie Portalu Rolnika?</a:t>
-                      </a:r>
-                      <a:endParaRPr lang="en-US" sz="1300" dirty="0"/>
-                    </a:p>
-                    <a:p>
-                      <a:pPr indent="0" marL="0">
-                        <a:buNone/>
-                      </a:pPr>
-                      <a:r>
-                        <a:rPr lang="en-US" sz="900" b="1" dirty="0">
-                          <a:solidFill>
-                            <a:schemeClr val="accent2"/>
-                          </a:solidFill>
-                        </a:rPr>
-                        <a:t>PILNE: SPOTKANIE 13.10</a:t>
-                      </a:r>
-                      <a:endParaRPr lang="en-US" sz="1300" dirty="0"/>
-                    </a:p>
-                  </a:txBody>
-                  <a:tcPr marL="109728" marR="109728" marT="45720" marB="45720" anchor="ctr">
-                    <a:lnL w="9525" cap="flat" cmpd="sng" algn="ctr">
-                      <a:solidFill>
-                        <a:srgbClr val="D5DBE2"/>
-                      </a:solidFill>
-                      <a:prstDash val="solid"/>
-                      <a:round/>
-                      <a:headEnd type="none" w="med" len="med"/>
-                      <a:tailEnd type="none" w="med" len="med"/>
-                    </a:lnL>
-                    <a:lnR w="9525" cap="flat" cmpd="sng" algn="ctr">
-                      <a:solidFill>
-                        <a:srgbClr val="D5DBE2"/>
-                      </a:solidFill>
-                      <a:prstDash val="solid"/>
-                      <a:round/>
-                      <a:headEnd type="none" w="med" len="med"/>
-                      <a:tailEnd type="none" w="med" len="med"/>
-                    </a:lnR>
-                    <a:lnT w="9525" cap="flat" cmpd="sng" algn="ctr">
-                      <a:solidFill>
-                        <a:srgbClr val="D5DBE2"/>
-                      </a:solidFill>
-                      <a:prstDash val="solid"/>
-                      <a:round/>
-                      <a:headEnd type="none" w="med" len="med"/>
-                      <a:tailEnd type="none" w="med" len="med"/>
-                    </a:lnT>
-                    <a:lnB w="9525" cap="flat" cmpd="sng" algn="ctr">
-                      <a:solidFill>
-                        <a:srgbClr val="D5DBE2"/>
-                      </a:solidFill>
-                      <a:prstDash val="solid"/>
-                      <a:round/>
-                      <a:headEnd type="none" w="med" len="med"/>
-                      <a:tailEnd type="none" w="med" len="med"/>
-                    </a:lnB>
-                  </a:tcPr>
-                </a:tc>
-              </a:tr>
-              <a:tr h="603504">
-                <a:tc>
-                  <a:txBody>
-                    <a:bodyPr/>
-                    <a:lstStyle/>
-                    <a:p>
-                      <a:pPr algn="ctr" indent="0" marL="0">
-                        <a:buNone/>
-                      </a:pPr>
-                      <a:r>
-                        <a:rPr lang="en-US" sz="1400" b="1" dirty="0">
-                          <a:solidFill>
-                            <a:schemeClr val="bg1"/>
-                          </a:solidFill>
-                        </a:rPr>
-                        <a:t>2</a:t>
-                      </a:r>
-                      <a:endParaRPr lang="en-US" sz="1400" dirty="0"/>
-                    </a:p>
-                  </a:txBody>
-                  <a:tcPr marL="109728" marR="109728" marT="45720" marB="45720" anchor="ctr">
-                    <a:lnL w="9525" cap="flat" cmpd="sng" algn="ctr">
-                      <a:solidFill>
-                        <a:srgbClr val="D5DBE2"/>
-                      </a:solidFill>
-                      <a:prstDash val="solid"/>
-                      <a:round/>
-                      <a:headEnd type="none" w="med" len="med"/>
-                      <a:tailEnd type="none" w="med" len="med"/>
-                    </a:lnL>
-                    <a:lnR w="9525" cap="flat" cmpd="sng" algn="ctr">
-                      <a:solidFill>
-                        <a:srgbClr val="D5DBE2"/>
-                      </a:solidFill>
-                      <a:prstDash val="solid"/>
-                      <a:round/>
-                      <a:headEnd type="none" w="med" len="med"/>
-                      <a:tailEnd type="none" w="med" len="med"/>
-                    </a:lnR>
-                    <a:lnT w="9525" cap="flat" cmpd="sng" algn="ctr">
-                      <a:solidFill>
-                        <a:srgbClr val="D5DBE2"/>
-                      </a:solidFill>
-                      <a:prstDash val="solid"/>
-                      <a:round/>
-                      <a:headEnd type="none" w="med" len="med"/>
-                      <a:tailEnd type="none" w="med" len="med"/>
-                    </a:lnT>
-                    <a:lnB w="9525" cap="flat" cmpd="sng" algn="ctr">
-                      <a:solidFill>
-                        <a:srgbClr val="D5DBE2"/>
-                      </a:solidFill>
-                      <a:prstDash val="solid"/>
-                      <a:round/>
-                      <a:headEnd type="none" w="med" len="med"/>
-                      <a:tailEnd type="none" w="med" len="med"/>
-                    </a:lnB>
-                    <a:solidFill>
-                      <a:schemeClr val="accent1"/>
-                    </a:solidFill>
-                  </a:tcPr>
-                </a:tc>
-                <a:tc>
-                  <a:txBody>
-                    <a:bodyPr/>
-                    <a:lstStyle/>
-                    <a:p>
-                      <a:pPr indent="0" marL="0">
-                        <a:buNone/>
-                      </a:pPr>
-                      <a:r>
-                        <a:rPr lang="en-US" sz="1300" b="1" dirty="0">
-                          <a:solidFill>
-                            <a:schemeClr val="accent1"/>
-                          </a:solidFill>
-                        </a:rPr>
-                        <a:t>Empik</a:t>
-                      </a:r>
-                      <a:endParaRPr lang="en-US" sz="1300" dirty="0"/>
-                    </a:p>
-                  </a:txBody>
-                  <a:tcPr marL="109728" marR="109728" marT="45720" marB="45720" anchor="ctr">
-                    <a:lnL w="9525" cap="flat" cmpd="sng" algn="ctr">
-                      <a:solidFill>
-                        <a:srgbClr val="D5DBE2"/>
-                      </a:solidFill>
-                      <a:prstDash val="solid"/>
-                      <a:round/>
-                      <a:headEnd type="none" w="med" len="med"/>
-                      <a:tailEnd type="none" w="med" len="med"/>
-                    </a:lnL>
-                    <a:lnR w="9525" cap="flat" cmpd="sng" algn="ctr">
-                      <a:solidFill>
-                        <a:srgbClr val="D5DBE2"/>
-                      </a:solidFill>
-                      <a:prstDash val="solid"/>
-                      <a:round/>
-                      <a:headEnd type="none" w="med" len="med"/>
-                      <a:tailEnd type="none" w="med" len="med"/>
-                    </a:lnR>
-                    <a:lnT w="9525" cap="flat" cmpd="sng" algn="ctr">
-                      <a:solidFill>
-                        <a:srgbClr val="D5DBE2"/>
-                      </a:solidFill>
-                      <a:prstDash val="solid"/>
-                      <a:round/>
-                      <a:headEnd type="none" w="med" len="med"/>
-                      <a:tailEnd type="none" w="med" len="med"/>
-                    </a:lnT>
-                    <a:lnB w="9525" cap="flat" cmpd="sng" algn="ctr">
-                      <a:solidFill>
-                        <a:srgbClr val="D5DBE2"/>
-                      </a:solidFill>
-                      <a:prstDash val="solid"/>
-                      <a:round/>
-                      <a:headEnd type="none" w="med" len="med"/>
-                      <a:tailEnd type="none" w="med" len="med"/>
-                    </a:lnB>
-                  </a:tcPr>
-                </a:tc>
-                <a:tc>
-                  <a:txBody>
-                    <a:bodyPr/>
-                    <a:lstStyle/>
-                    <a:p>
-                      <a:pPr indent="0" marL="0">
-                        <a:buNone/>
-                      </a:pPr>
-                      <a:r>
-                        <a:rPr lang="en-US" sz="1300" dirty="0">
-                          <a:solidFill>
-                            <a:schemeClr val="tx1"/>
-                          </a:solidFill>
-                        </a:rPr>
-                        <a:t>Czy zostało coś ustalone poza spotkaniami? Na jakim poziomie jest zainteresowanie?</a:t>
-                      </a:r>
-                      <a:endParaRPr lang="en-US" sz="1300" dirty="0"/>
-                    </a:p>
-                  </a:txBody>
-                  <a:tcPr marL="109728" marR="109728" marT="45720" marB="45720" anchor="ctr">
-                    <a:lnL w="9525" cap="flat" cmpd="sng" algn="ctr">
-                      <a:solidFill>
-                        <a:srgbClr val="D5DBE2"/>
-                      </a:solidFill>
-                      <a:prstDash val="solid"/>
-                      <a:round/>
-                      <a:headEnd type="none" w="med" len="med"/>
-                      <a:tailEnd type="none" w="med" len="med"/>
-                    </a:lnL>
-                    <a:lnR w="9525" cap="flat" cmpd="sng" algn="ctr">
-                      <a:solidFill>
-                        <a:srgbClr val="D5DBE2"/>
-                      </a:solidFill>
-                      <a:prstDash val="solid"/>
-                      <a:round/>
-                      <a:headEnd type="none" w="med" len="med"/>
-                      <a:tailEnd type="none" w="med" len="med"/>
-                    </a:lnR>
-                    <a:lnT w="9525" cap="flat" cmpd="sng" algn="ctr">
-                      <a:solidFill>
-                        <a:srgbClr val="D5DBE2"/>
-                      </a:solidFill>
-                      <a:prstDash val="solid"/>
-                      <a:round/>
-                      <a:headEnd type="none" w="med" len="med"/>
-                      <a:tailEnd type="none" w="med" len="med"/>
-                    </a:lnT>
-                    <a:lnB w="9525" cap="flat" cmpd="sng" algn="ctr">
-                      <a:solidFill>
-                        <a:srgbClr val="D5DBE2"/>
-                      </a:solidFill>
-                      <a:prstDash val="solid"/>
-                      <a:round/>
-                      <a:headEnd type="none" w="med" len="med"/>
-                      <a:tailEnd type="none" w="med" len="med"/>
-                    </a:lnB>
-                  </a:tcPr>
-                </a:tc>
-              </a:tr>
-              <a:tr h="603504">
-                <a:tc>
-                  <a:txBody>
-                    <a:bodyPr/>
-                    <a:lstStyle/>
-                    <a:p>
-                      <a:pPr algn="ctr" indent="0" marL="0">
-                        <a:buNone/>
-                      </a:pPr>
-                      <a:r>
-                        <a:rPr lang="en-US" sz="1400" b="1" dirty="0">
-                          <a:solidFill>
-                            <a:schemeClr val="bg1"/>
-                          </a:solidFill>
-                        </a:rPr>
-                        <a:t>3</a:t>
-                      </a:r>
-                      <a:endParaRPr lang="en-US" sz="1400" dirty="0"/>
-                    </a:p>
-                  </a:txBody>
-                  <a:tcPr marL="109728" marR="109728" marT="45720" marB="45720" anchor="ctr">
-                    <a:lnL w="9525" cap="flat" cmpd="sng" algn="ctr">
-                      <a:solidFill>
-                        <a:srgbClr val="D5DBE2"/>
-                      </a:solidFill>
-                      <a:prstDash val="solid"/>
-                      <a:round/>
-                      <a:headEnd type="none" w="med" len="med"/>
-                      <a:tailEnd type="none" w="med" len="med"/>
-                    </a:lnL>
-                    <a:lnR w="9525" cap="flat" cmpd="sng" algn="ctr">
-                      <a:solidFill>
-                        <a:srgbClr val="D5DBE2"/>
-                      </a:solidFill>
-                      <a:prstDash val="solid"/>
-                      <a:round/>
-                      <a:headEnd type="none" w="med" len="med"/>
-                      <a:tailEnd type="none" w="med" len="med"/>
-                    </a:lnR>
-                    <a:lnT w="9525" cap="flat" cmpd="sng" algn="ctr">
-                      <a:solidFill>
-                        <a:srgbClr val="D5DBE2"/>
-                      </a:solidFill>
-                      <a:prstDash val="solid"/>
-                      <a:round/>
-                      <a:headEnd type="none" w="med" len="med"/>
-                      <a:tailEnd type="none" w="med" len="med"/>
-                    </a:lnT>
-                    <a:lnB w="9525" cap="flat" cmpd="sng" algn="ctr">
-                      <a:solidFill>
-                        <a:srgbClr val="D5DBE2"/>
-                      </a:solidFill>
-                      <a:prstDash val="solid"/>
-                      <a:round/>
-                      <a:headEnd type="none" w="med" len="med"/>
-                      <a:tailEnd type="none" w="med" len="med"/>
-                    </a:lnB>
-                    <a:solidFill>
-                      <a:schemeClr val="accent1"/>
-                    </a:solidFill>
-                  </a:tcPr>
-                </a:tc>
-                <a:tc>
-                  <a:txBody>
-                    <a:bodyPr/>
-                    <a:lstStyle/>
-                    <a:p>
-                      <a:pPr indent="0" marL="0">
-                        <a:buNone/>
-                      </a:pPr>
-                      <a:r>
-                        <a:rPr lang="en-US" sz="1300" b="1" dirty="0">
-                          <a:solidFill>
-                            <a:schemeClr val="accent1"/>
-                          </a:solidFill>
-                        </a:rPr>
-                        <a:t>PZU</a:t>
-                      </a:r>
-                      <a:endParaRPr lang="en-US" sz="1300" dirty="0"/>
-                    </a:p>
-                  </a:txBody>
-                  <a:tcPr marL="109728" marR="109728" marT="45720" marB="45720" anchor="ctr">
-                    <a:lnL w="9525" cap="flat" cmpd="sng" algn="ctr">
-                      <a:solidFill>
-                        <a:srgbClr val="D5DBE2"/>
-                      </a:solidFill>
-                      <a:prstDash val="solid"/>
-                      <a:round/>
-                      <a:headEnd type="none" w="med" len="med"/>
-                      <a:tailEnd type="none" w="med" len="med"/>
-                    </a:lnL>
-                    <a:lnR w="9525" cap="flat" cmpd="sng" algn="ctr">
-                      <a:solidFill>
-                        <a:srgbClr val="D5DBE2"/>
-                      </a:solidFill>
-                      <a:prstDash val="solid"/>
-                      <a:round/>
-                      <a:headEnd type="none" w="med" len="med"/>
-                      <a:tailEnd type="none" w="med" len="med"/>
-                    </a:lnR>
-                    <a:lnT w="9525" cap="flat" cmpd="sng" algn="ctr">
-                      <a:solidFill>
-                        <a:srgbClr val="D5DBE2"/>
-                      </a:solidFill>
-                      <a:prstDash val="solid"/>
-                      <a:round/>
-                      <a:headEnd type="none" w="med" len="med"/>
-                      <a:tailEnd type="none" w="med" len="med"/>
-                    </a:lnT>
-                    <a:lnB w="9525" cap="flat" cmpd="sng" algn="ctr">
-                      <a:solidFill>
-                        <a:srgbClr val="D5DBE2"/>
-                      </a:solidFill>
-                      <a:prstDash val="solid"/>
-                      <a:round/>
-                      <a:headEnd type="none" w="med" len="med"/>
-                      <a:tailEnd type="none" w="med" len="med"/>
-                    </a:lnB>
-                  </a:tcPr>
-                </a:tc>
-                <a:tc>
-                  <a:txBody>
-                    <a:bodyPr/>
-                    <a:lstStyle/>
-                    <a:p>
-                      <a:pPr indent="0" marL="0">
-                        <a:buNone/>
-                      </a:pPr>
-                      <a:r>
-                        <a:rPr lang="en-US" sz="1300" dirty="0">
-                          <a:solidFill>
-                            <a:schemeClr val="tx1"/>
-                          </a:solidFill>
-                        </a:rPr>
-                        <a:t>Czy rozszerzamy rozmowy z PZU o finansowanie i inwestycje?</a:t>
-                      </a:r>
-                      <a:endParaRPr lang="en-US" sz="1300" dirty="0"/>
-                    </a:p>
-                  </a:txBody>
-                  <a:tcPr marL="109728" marR="109728" marT="45720" marB="45720" anchor="ctr">
-                    <a:lnL w="9525" cap="flat" cmpd="sng" algn="ctr">
-                      <a:solidFill>
-                        <a:srgbClr val="D5DBE2"/>
-                      </a:solidFill>
-                      <a:prstDash val="solid"/>
-                      <a:round/>
-                      <a:headEnd type="none" w="med" len="med"/>
-                      <a:tailEnd type="none" w="med" len="med"/>
-                    </a:lnL>
-                    <a:lnR w="9525" cap="flat" cmpd="sng" algn="ctr">
-                      <a:solidFill>
-                        <a:srgbClr val="D5DBE2"/>
-                      </a:solidFill>
-                      <a:prstDash val="solid"/>
-                      <a:round/>
-                      <a:headEnd type="none" w="med" len="med"/>
-                      <a:tailEnd type="none" w="med" len="med"/>
-                    </a:lnR>
-                    <a:lnT w="9525" cap="flat" cmpd="sng" algn="ctr">
-                      <a:solidFill>
-                        <a:srgbClr val="D5DBE2"/>
-                      </a:solidFill>
-                      <a:prstDash val="solid"/>
-                      <a:round/>
-                      <a:headEnd type="none" w="med" len="med"/>
-                      <a:tailEnd type="none" w="med" len="med"/>
-                    </a:lnT>
-                    <a:lnB w="9525" cap="flat" cmpd="sng" algn="ctr">
-                      <a:solidFill>
-                        <a:srgbClr val="D5DBE2"/>
-                      </a:solidFill>
-                      <a:prstDash val="solid"/>
-                      <a:round/>
-                      <a:headEnd type="none" w="med" len="med"/>
-                      <a:tailEnd type="none" w="med" len="med"/>
-                    </a:lnB>
-                  </a:tcPr>
-                </a:tc>
-              </a:tr>
-              <a:tr h="603504">
-                <a:tc>
-                  <a:txBody>
-                    <a:bodyPr/>
-                    <a:lstStyle/>
-                    <a:p>
-                      <a:pPr algn="ctr" indent="0" marL="0">
-                        <a:buNone/>
-                      </a:pPr>
-                      <a:r>
-                        <a:rPr lang="en-US" sz="1400" b="1" dirty="0">
-                          <a:solidFill>
-                            <a:schemeClr val="bg1"/>
-                          </a:solidFill>
-                        </a:rPr>
-                        <a:t>4</a:t>
-                      </a:r>
-                      <a:endParaRPr lang="en-US" sz="1400" dirty="0"/>
-                    </a:p>
-                  </a:txBody>
-                  <a:tcPr marL="109728" marR="109728" marT="45720" marB="45720" anchor="ctr">
-                    <a:lnL w="9525" cap="flat" cmpd="sng" algn="ctr">
-                      <a:solidFill>
-                        <a:srgbClr val="D5DBE2"/>
-                      </a:solidFill>
-                      <a:prstDash val="solid"/>
-                      <a:round/>
-                      <a:headEnd type="none" w="med" len="med"/>
-                      <a:tailEnd type="none" w="med" len="med"/>
-                    </a:lnL>
-                    <a:lnR w="9525" cap="flat" cmpd="sng" algn="ctr">
-                      <a:solidFill>
-                        <a:srgbClr val="D5DBE2"/>
-                      </a:solidFill>
-                      <a:prstDash val="solid"/>
-                      <a:round/>
-                      <a:headEnd type="none" w="med" len="med"/>
-                      <a:tailEnd type="none" w="med" len="med"/>
-                    </a:lnR>
-                    <a:lnT w="9525" cap="flat" cmpd="sng" algn="ctr">
-                      <a:solidFill>
-                        <a:srgbClr val="D5DBE2"/>
-                      </a:solidFill>
-                      <a:prstDash val="solid"/>
-                      <a:round/>
-                      <a:headEnd type="none" w="med" len="med"/>
-                      <a:tailEnd type="none" w="med" len="med"/>
-                    </a:lnT>
-                    <a:lnB w="9525" cap="flat" cmpd="sng" algn="ctr">
-                      <a:solidFill>
-                        <a:srgbClr val="D5DBE2"/>
-                      </a:solidFill>
-                      <a:prstDash val="solid"/>
-                      <a:round/>
-                      <a:headEnd type="none" w="med" len="med"/>
-                      <a:tailEnd type="none" w="med" len="med"/>
-                    </a:lnB>
-                    <a:solidFill>
-                      <a:schemeClr val="accent1"/>
-                    </a:solidFill>
-                  </a:tcPr>
-                </a:tc>
-                <a:tc>
-                  <a:txBody>
-                    <a:bodyPr/>
-                    <a:lstStyle/>
-                    <a:p>
-                      <a:pPr indent="0" marL="0">
-                        <a:buNone/>
-                      </a:pPr>
-                      <a:r>
-                        <a:rPr lang="en-US" sz="1300" b="1" dirty="0">
-                          <a:solidFill>
-                            <a:schemeClr val="accent1"/>
-                          </a:solidFill>
-                        </a:rPr>
-                        <a:t>Farmster</a:t>
-                      </a:r>
-                      <a:endParaRPr lang="en-US" sz="1300" dirty="0"/>
-                    </a:p>
-                  </a:txBody>
-                  <a:tcPr marL="109728" marR="109728" marT="45720" marB="45720" anchor="ctr">
-                    <a:lnL w="9525" cap="flat" cmpd="sng" algn="ctr">
-                      <a:solidFill>
-                        <a:srgbClr val="D5DBE2"/>
-                      </a:solidFill>
-                      <a:prstDash val="solid"/>
-                      <a:round/>
-                      <a:headEnd type="none" w="med" len="med"/>
-                      <a:tailEnd type="none" w="med" len="med"/>
-                    </a:lnL>
-                    <a:lnR w="9525" cap="flat" cmpd="sng" algn="ctr">
-                      <a:solidFill>
-                        <a:srgbClr val="D5DBE2"/>
-                      </a:solidFill>
-                      <a:prstDash val="solid"/>
-                      <a:round/>
-                      <a:headEnd type="none" w="med" len="med"/>
-                      <a:tailEnd type="none" w="med" len="med"/>
-                    </a:lnR>
-                    <a:lnT w="9525" cap="flat" cmpd="sng" algn="ctr">
-                      <a:solidFill>
-                        <a:srgbClr val="D5DBE2"/>
-                      </a:solidFill>
-                      <a:prstDash val="solid"/>
-                      <a:round/>
-                      <a:headEnd type="none" w="med" len="med"/>
-                      <a:tailEnd type="none" w="med" len="med"/>
-                    </a:lnT>
-                    <a:lnB w="9525" cap="flat" cmpd="sng" algn="ctr">
-                      <a:solidFill>
-                        <a:srgbClr val="D5DBE2"/>
-                      </a:solidFill>
-                      <a:prstDash val="solid"/>
-                      <a:round/>
-                      <a:headEnd type="none" w="med" len="med"/>
-                      <a:tailEnd type="none" w="med" len="med"/>
-                    </a:lnB>
-                  </a:tcPr>
-                </a:tc>
-                <a:tc>
-                  <a:txBody>
-                    <a:bodyPr/>
-                    <a:lstStyle/>
-                    <a:p>
-                      <a:pPr indent="0" marL="0">
-                        <a:buNone/>
-                      </a:pPr>
-                      <a:r>
-                        <a:rPr lang="en-US" sz="1300" dirty="0">
-                          <a:solidFill>
-                            <a:schemeClr val="tx1"/>
-                          </a:solidFill>
-                        </a:rPr>
-                        <a:t>Czy rozpatrujemy wykupienie AgriSolutions, dostawcy Farmstera?</a:t>
-                      </a:r>
-                      <a:endParaRPr lang="en-US" sz="1300" dirty="0"/>
-                    </a:p>
-                  </a:txBody>
-                  <a:tcPr marL="109728" marR="109728" marT="45720" marB="45720" anchor="ctr">
-                    <a:lnL w="9525" cap="flat" cmpd="sng" algn="ctr">
-                      <a:solidFill>
-                        <a:srgbClr val="D5DBE2"/>
-                      </a:solidFill>
-                      <a:prstDash val="solid"/>
-                      <a:round/>
-                      <a:headEnd type="none" w="med" len="med"/>
-                      <a:tailEnd type="none" w="med" len="med"/>
-                    </a:lnL>
-                    <a:lnR w="9525" cap="flat" cmpd="sng" algn="ctr">
-                      <a:solidFill>
-                        <a:srgbClr val="D5DBE2"/>
-                      </a:solidFill>
-                      <a:prstDash val="solid"/>
-                      <a:round/>
-                      <a:headEnd type="none" w="med" len="med"/>
-                      <a:tailEnd type="none" w="med" len="med"/>
-                    </a:lnR>
-                    <a:lnT w="9525" cap="flat" cmpd="sng" algn="ctr">
-                      <a:solidFill>
-                        <a:srgbClr val="D5DBE2"/>
-                      </a:solidFill>
-                      <a:prstDash val="solid"/>
-                      <a:round/>
-                      <a:headEnd type="none" w="med" len="med"/>
-                      <a:tailEnd type="none" w="med" len="med"/>
-                    </a:lnT>
-                    <a:lnB w="9525" cap="flat" cmpd="sng" algn="ctr">
-                      <a:solidFill>
-                        <a:srgbClr val="D5DBE2"/>
-                      </a:solidFill>
-                      <a:prstDash val="solid"/>
-                      <a:round/>
-                      <a:headEnd type="none" w="med" len="med"/>
-                      <a:tailEnd type="none" w="med" len="med"/>
-                    </a:lnB>
-                  </a:tcPr>
-                </a:tc>
-              </a:tr>
-              <a:tr h="603504">
-                <a:tc>
-                  <a:txBody>
-                    <a:bodyPr/>
-                    <a:lstStyle/>
-                    <a:p>
-                      <a:pPr algn="ctr" indent="0" marL="0">
-                        <a:buNone/>
-                      </a:pPr>
-                      <a:r>
-                        <a:rPr lang="en-US" sz="1400" b="1" dirty="0">
-                          <a:solidFill>
-                            <a:schemeClr val="bg1"/>
-                          </a:solidFill>
-                        </a:rPr>
-                        <a:t>5</a:t>
-                      </a:r>
-                      <a:endParaRPr lang="en-US" sz="1400" dirty="0"/>
-                    </a:p>
-                  </a:txBody>
-                  <a:tcPr marL="109728" marR="109728" marT="45720" marB="45720" anchor="ctr">
-                    <a:lnL w="9525" cap="flat" cmpd="sng" algn="ctr">
-                      <a:solidFill>
-                        <a:srgbClr val="D5DBE2"/>
-                      </a:solidFill>
-                      <a:prstDash val="solid"/>
-                      <a:round/>
-                      <a:headEnd type="none" w="med" len="med"/>
-                      <a:tailEnd type="none" w="med" len="med"/>
-                    </a:lnL>
-                    <a:lnR w="9525" cap="flat" cmpd="sng" algn="ctr">
-                      <a:solidFill>
-                        <a:srgbClr val="D5DBE2"/>
-                      </a:solidFill>
-                      <a:prstDash val="solid"/>
-                      <a:round/>
-                      <a:headEnd type="none" w="med" len="med"/>
-                      <a:tailEnd type="none" w="med" len="med"/>
-                    </a:lnR>
-                    <a:lnT w="9525" cap="flat" cmpd="sng" algn="ctr">
-                      <a:solidFill>
-                        <a:srgbClr val="D5DBE2"/>
-                      </a:solidFill>
-                      <a:prstDash val="solid"/>
-                      <a:round/>
-                      <a:headEnd type="none" w="med" len="med"/>
-                      <a:tailEnd type="none" w="med" len="med"/>
-                    </a:lnT>
-                    <a:lnB w="9525" cap="flat" cmpd="sng" algn="ctr">
-                      <a:solidFill>
-                        <a:srgbClr val="D5DBE2"/>
-                      </a:solidFill>
-                      <a:prstDash val="solid"/>
-                      <a:round/>
-                      <a:headEnd type="none" w="med" len="med"/>
-                      <a:tailEnd type="none" w="med" len="med"/>
-                    </a:lnB>
-                    <a:solidFill>
-                      <a:schemeClr val="accent1"/>
-                    </a:solidFill>
-                  </a:tcPr>
-                </a:tc>
-                <a:tc>
-                  <a:txBody>
-                    <a:bodyPr/>
-                    <a:lstStyle/>
-                    <a:p>
-                      <a:pPr indent="0" marL="0">
-                        <a:buNone/>
-                      </a:pPr>
-                      <a:r>
-                        <a:rPr lang="en-US" sz="1300" b="1" dirty="0">
-                          <a:solidFill>
-                            <a:schemeClr val="accent1"/>
-                          </a:solidFill>
-                        </a:rPr>
-                        <a:t>Strategia</a:t>
-                      </a:r>
-                      <a:endParaRPr lang="en-US" sz="1300" dirty="0"/>
-                    </a:p>
-                  </a:txBody>
-                  <a:tcPr marL="109728" marR="109728" marT="45720" marB="45720" anchor="ctr">
-                    <a:lnL w="9525" cap="flat" cmpd="sng" algn="ctr">
-                      <a:solidFill>
-                        <a:srgbClr val="D5DBE2"/>
-                      </a:solidFill>
-                      <a:prstDash val="solid"/>
-                      <a:round/>
-                      <a:headEnd type="none" w="med" len="med"/>
-                      <a:tailEnd type="none" w="med" len="med"/>
-                    </a:lnL>
-                    <a:lnR w="9525" cap="flat" cmpd="sng" algn="ctr">
-                      <a:solidFill>
-                        <a:srgbClr val="D5DBE2"/>
-                      </a:solidFill>
-                      <a:prstDash val="solid"/>
-                      <a:round/>
-                      <a:headEnd type="none" w="med" len="med"/>
-                      <a:tailEnd type="none" w="med" len="med"/>
-                    </a:lnR>
-                    <a:lnT w="9525" cap="flat" cmpd="sng" algn="ctr">
-                      <a:solidFill>
-                        <a:srgbClr val="D5DBE2"/>
-                      </a:solidFill>
-                      <a:prstDash val="solid"/>
-                      <a:round/>
-                      <a:headEnd type="none" w="med" len="med"/>
-                      <a:tailEnd type="none" w="med" len="med"/>
-                    </a:lnT>
-                    <a:lnB w="9525" cap="flat" cmpd="sng" algn="ctr">
-                      <a:solidFill>
-                        <a:srgbClr val="D5DBE2"/>
-                      </a:solidFill>
-                      <a:prstDash val="solid"/>
-                      <a:round/>
-                      <a:headEnd type="none" w="med" len="med"/>
-                      <a:tailEnd type="none" w="med" len="med"/>
-                    </a:lnB>
-                  </a:tcPr>
-                </a:tc>
-                <a:tc>
-                  <a:txBody>
-                    <a:bodyPr/>
-                    <a:lstStyle/>
-                    <a:p>
-                      <a:pPr indent="0" marL="0">
-                        <a:buNone/>
-                      </a:pPr>
-                      <a:r>
-                        <a:rPr lang="en-US" sz="1300" dirty="0">
-                          <a:solidFill>
-                            <a:schemeClr val="tx1"/>
-                          </a:solidFill>
-                        </a:rPr>
-                        <a:t>Czy dołączamy GAię do innych strategii budowanych w Grupie?</a:t>
-                      </a:r>
-                      <a:endParaRPr lang="en-US" sz="1300" dirty="0"/>
-                    </a:p>
-                  </a:txBody>
-                  <a:tcPr marL="109728" marR="109728" marT="45720" marB="45720" anchor="ctr">
-                    <a:lnL w="9525" cap="flat" cmpd="sng" algn="ctr">
-                      <a:solidFill>
-                        <a:srgbClr val="D5DBE2"/>
-                      </a:solidFill>
-                      <a:prstDash val="solid"/>
-                      <a:round/>
-                      <a:headEnd type="none" w="med" len="med"/>
-                      <a:tailEnd type="none" w="med" len="med"/>
-                    </a:lnL>
-                    <a:lnR w="9525" cap="flat" cmpd="sng" algn="ctr">
-                      <a:solidFill>
-                        <a:srgbClr val="D5DBE2"/>
-                      </a:solidFill>
-                      <a:prstDash val="solid"/>
-                      <a:round/>
-                      <a:headEnd type="none" w="med" len="med"/>
-                      <a:tailEnd type="none" w="med" len="med"/>
-                    </a:lnR>
-                    <a:lnT w="9525" cap="flat" cmpd="sng" algn="ctr">
-                      <a:solidFill>
-                        <a:srgbClr val="D5DBE2"/>
-                      </a:solidFill>
-                      <a:prstDash val="solid"/>
-                      <a:round/>
-                      <a:headEnd type="none" w="med" len="med"/>
-                      <a:tailEnd type="none" w="med" len="med"/>
-                    </a:lnT>
-                    <a:lnB w="9525" cap="flat" cmpd="sng" algn="ctr">
-                      <a:solidFill>
-                        <a:srgbClr val="D5DBE2"/>
-                      </a:solidFill>
-                      <a:prstDash val="solid"/>
-                      <a:round/>
-                      <a:headEnd type="none" w="med" len="med"/>
-                      <a:tailEnd type="none" w="med" len="med"/>
-                    </a:lnB>
-                  </a:tcPr>
-                </a:tc>
-              </a:tr>
-            </a:tbl>
-          </a:graphicData>
-        </a:graphic>
-      </p:graphicFrame>
-      <p:sp>
-        <p:nvSpPr>
-          <p:cNvPr id="25" name="Slide Number Placeholder 0"/>
-          <p:cNvSpPr>
-            <a:spLocks noGrp="1"/>
-          </p:cNvSpPr>
-          <p:nvPr>
-            <p:ph type="sldNum" sz="quarter" idx="4294967295"/>
-          </p:nvPr>
-        </p:nvSpPr>
-        <p:spPr>
-          <a:xfrm>
-            <a:off x="8321040" y="4828032"/>
-            <a:ext cx="365760" cy="182880"/>
-          </a:xfrm>
-          <a:prstGeom prst="rect">
-            <a:avLst/>
-          </a:prstGeom>
-          <a:extLst>
-            <a:ext uri="{C572A759-6A51-4108-AA02-DFA0A04FC94B}">
-              <ma14:wrappingTextBoxFlag xmlns:ma14="http://schemas.microsoft.com/office/mac/drawingml/2011/main" val="0"/>
-            </a:ext>
-          </a:extLst>
-        </p:spPr>
-        <p:txBody>
-          <a:bodyPr/>
-          <a:lstStyle>
-            <a:lvl1pPr>
-              <a:defRPr sz="900">
-                <a:solidFill>
-                  <a:schemeClr val="accent3"/>
-                </a:solidFill>
-              </a:defRPr>
-            </a:lvl1pPr>
-          </a:lstStyle>
-          <a:p>
-            <a:pPr algn="r"/>
-            <a:fld id="{F7021451-1387-4CA6-816F-3879F97B5CBC}" type="slidenum">
-              <a:rPr b="0" lang="en-US"/>
-              <a:t>4</a:t>
-            </a:fld>
-            <a:endParaRPr lang="en-US"/>
-          </a:p>
-        </p:txBody>
-      </p:sp>
     </p:spTree>
   </p:cSld>
   <p:clrMapOvr>

</xml_diff>

<commit_message>
Dopracuj tabelę statusu: bez scalonych komórek, stałe wysokości wierszy, zapas na dole
Co-Authored-By: Claude Opus 5.5 <noreply@anthropic.com>
Claude-Session: https://claude.ai/code/session_01HLzk51tscwKpTxY48VqnmK
</commit_message>
<xml_diff>
--- a/GAia_Status_dla_Prezesa.pptx
+++ b/GAia_Status_dla_Prezesa.pptx
@@ -107,7 +107,7 @@
   <p:extLst>
     <p:ext uri="{521415D9-36F7-43E2-AB2F-B90AF26B5E84}">
       <p14:sectionLst xmlns:p14="http://schemas.microsoft.com/office/powerpoint/2010/main">
-        <p14:section name="Status" id="{74199ade-f795-37de-8fcf-ad65f2b27bfe}">
+        <p14:section name="Status" id="{9f31b6d0-c568-d727-4f1f-5cdfdcf40259}">
           <p14:sldIdLst>
             <p14:sldId id="256"/>
           </p14:sldIdLst>
@@ -1043,7 +1043,7 @@
           </p:nvPr>
         </p:nvGraphicFramePr>
         <p:xfrm>
-          <a:off x="365760" y="731520"/>
+          <a:off x="365760" y="713232"/>
           <a:ext cx="8412480" cy="914400"/>
         </p:xfrm>
         <a:graphic>
@@ -1051,11 +1051,11 @@
             <a:tbl>
               <a:tblPr/>
               <a:tblGrid>
-                <a:gridCol w="1417320"/>
-                <a:gridCol w="4343400"/>
+                <a:gridCol w="1783080"/>
+                <a:gridCol w="3977640"/>
                 <a:gridCol w="2651760"/>
               </a:tblGrid>
-              <a:tr h="0">
+              <a:tr h="256032">
                 <a:tc>
                   <a:txBody>
                     <a:bodyPr/>
@@ -1076,41 +1076,17 @@
                     </a:p>
                   </a:txBody>
                   <a:tcPr marL="73152" marR="73152" marT="27432" marB="27432" anchor="ctr">
-                    <a:lnL w="9525" cap="flat" cmpd="sng" algn="ctr">
-                      <a:solidFill>
-                        <a:srgbClr val="D5DBE2"/>
-                      </a:solidFill>
-                      <a:prstDash val="solid"/>
-                      <a:round/>
-                      <a:headEnd type="none" w="med" len="med"/>
-                      <a:tailEnd type="none" w="med" len="med"/>
-                    </a:lnL>
-                    <a:lnR w="9525" cap="flat" cmpd="sng" algn="ctr">
-                      <a:solidFill>
-                        <a:srgbClr val="D5DBE2"/>
-                      </a:solidFill>
-                      <a:prstDash val="solid"/>
-                      <a:round/>
-                      <a:headEnd type="none" w="med" len="med"/>
-                      <a:tailEnd type="none" w="med" len="med"/>
-                    </a:lnR>
-                    <a:lnT w="9525" cap="flat" cmpd="sng" algn="ctr">
-                      <a:solidFill>
-                        <a:srgbClr val="D5DBE2"/>
-                      </a:solidFill>
-                      <a:prstDash val="solid"/>
-                      <a:round/>
-                      <a:headEnd type="none" w="med" len="med"/>
-                      <a:tailEnd type="none" w="med" len="med"/>
-                    </a:lnT>
-                    <a:lnB w="9525" cap="flat" cmpd="sng" algn="ctr">
-                      <a:solidFill>
-                        <a:srgbClr val="D5DBE2"/>
-                      </a:solidFill>
-                      <a:prstDash val="solid"/>
-                      <a:round/>
-                      <a:headEnd type="none" w="med" len="med"/>
-                      <a:tailEnd type="none" w="med" len="med"/>
+                    <a:lnL w="0" cap="flat" cmpd="sng" algn="ctr">
+                      <a:noFill/>
+                    </a:lnL>
+                    <a:lnR w="0" cap="flat" cmpd="sng" algn="ctr">
+                      <a:noFill/>
+                    </a:lnR>
+                    <a:lnT w="0" cap="flat" cmpd="sng" algn="ctr">
+                      <a:noFill/>
+                    </a:lnT>
+                    <a:lnB w="0" cap="flat" cmpd="sng" algn="ctr">
+                      <a:noFill/>
                     </a:lnB>
                     <a:solidFill>
                       <a:schemeClr val="accent1"/>
@@ -1137,41 +1113,17 @@
                     </a:p>
                   </a:txBody>
                   <a:tcPr marL="73152" marR="73152" marT="27432" marB="27432" anchor="ctr">
-                    <a:lnL w="9525" cap="flat" cmpd="sng" algn="ctr">
-                      <a:solidFill>
-                        <a:srgbClr val="D5DBE2"/>
-                      </a:solidFill>
-                      <a:prstDash val="solid"/>
-                      <a:round/>
-                      <a:headEnd type="none" w="med" len="med"/>
-                      <a:tailEnd type="none" w="med" len="med"/>
-                    </a:lnL>
-                    <a:lnR w="9525" cap="flat" cmpd="sng" algn="ctr">
-                      <a:solidFill>
-                        <a:srgbClr val="D5DBE2"/>
-                      </a:solidFill>
-                      <a:prstDash val="solid"/>
-                      <a:round/>
-                      <a:headEnd type="none" w="med" len="med"/>
-                      <a:tailEnd type="none" w="med" len="med"/>
-                    </a:lnR>
-                    <a:lnT w="9525" cap="flat" cmpd="sng" algn="ctr">
-                      <a:solidFill>
-                        <a:srgbClr val="D5DBE2"/>
-                      </a:solidFill>
-                      <a:prstDash val="solid"/>
-                      <a:round/>
-                      <a:headEnd type="none" w="med" len="med"/>
-                      <a:tailEnd type="none" w="med" len="med"/>
-                    </a:lnT>
-                    <a:lnB w="9525" cap="flat" cmpd="sng" algn="ctr">
-                      <a:solidFill>
-                        <a:srgbClr val="D5DBE2"/>
-                      </a:solidFill>
-                      <a:prstDash val="solid"/>
-                      <a:round/>
-                      <a:headEnd type="none" w="med" len="med"/>
-                      <a:tailEnd type="none" w="med" len="med"/>
+                    <a:lnL w="0" cap="flat" cmpd="sng" algn="ctr">
+                      <a:noFill/>
+                    </a:lnL>
+                    <a:lnR w="0" cap="flat" cmpd="sng" algn="ctr">
+                      <a:noFill/>
+                    </a:lnR>
+                    <a:lnT w="0" cap="flat" cmpd="sng" algn="ctr">
+                      <a:noFill/>
+                    </a:lnT>
+                    <a:lnB w="0" cap="flat" cmpd="sng" algn="ctr">
+                      <a:noFill/>
                     </a:lnB>
                     <a:solidFill>
                       <a:schemeClr val="accent1"/>
@@ -1198,41 +1150,17 @@
                     </a:p>
                   </a:txBody>
                   <a:tcPr marL="73152" marR="73152" marT="27432" marB="27432" anchor="ctr">
-                    <a:lnL w="9525" cap="flat" cmpd="sng" algn="ctr">
-                      <a:solidFill>
-                        <a:srgbClr val="D5DBE2"/>
-                      </a:solidFill>
-                      <a:prstDash val="solid"/>
-                      <a:round/>
-                      <a:headEnd type="none" w="med" len="med"/>
-                      <a:tailEnd type="none" w="med" len="med"/>
-                    </a:lnL>
-                    <a:lnR w="9525" cap="flat" cmpd="sng" algn="ctr">
-                      <a:solidFill>
-                        <a:srgbClr val="D5DBE2"/>
-                      </a:solidFill>
-                      <a:prstDash val="solid"/>
-                      <a:round/>
-                      <a:headEnd type="none" w="med" len="med"/>
-                      <a:tailEnd type="none" w="med" len="med"/>
-                    </a:lnR>
-                    <a:lnT w="9525" cap="flat" cmpd="sng" algn="ctr">
-                      <a:solidFill>
-                        <a:srgbClr val="D5DBE2"/>
-                      </a:solidFill>
-                      <a:prstDash val="solid"/>
-                      <a:round/>
-                      <a:headEnd type="none" w="med" len="med"/>
-                      <a:tailEnd type="none" w="med" len="med"/>
-                    </a:lnT>
-                    <a:lnB w="9525" cap="flat" cmpd="sng" algn="ctr">
-                      <a:solidFill>
-                        <a:srgbClr val="D5DBE2"/>
-                      </a:solidFill>
-                      <a:prstDash val="solid"/>
-                      <a:round/>
-                      <a:headEnd type="none" w="med" len="med"/>
-                      <a:tailEnd type="none" w="med" len="med"/>
+                    <a:lnL w="0" cap="flat" cmpd="sng" algn="ctr">
+                      <a:noFill/>
+                    </a:lnL>
+                    <a:lnR w="0" cap="flat" cmpd="sng" algn="ctr">
+                      <a:noFill/>
+                    </a:lnR>
+                    <a:lnT w="0" cap="flat" cmpd="sng" algn="ctr">
+                      <a:noFill/>
+                    </a:lnT>
+                    <a:lnB w="0" cap="flat" cmpd="sng" algn="ctr">
+                      <a:noFill/>
                     </a:lnB>
                     <a:solidFill>
                       <a:schemeClr val="accent2"/>
@@ -1240,8 +1168,8 @@
                   </a:tcPr>
                 </a:tc>
               </a:tr>
-              <a:tr h="0">
-                <a:tc gridSpan="3">
+              <a:tr h="201168">
+                <a:tc>
                   <a:txBody>
                     <a:bodyPr/>
                     <a:lstStyle/>
@@ -1250,14 +1178,14 @@
                         <a:buNone/>
                       </a:pPr>
                       <a:r>
-                        <a:rPr lang="en-US" sz="850" b="1" spc="100" kern="0" dirty="0">
+                        <a:rPr lang="en-US" sz="950" b="1" spc="10" kern="0" dirty="0">
                           <a:solidFill>
                             <a:schemeClr val="accent1"/>
                           </a:solidFill>
                         </a:rPr>
-                        <a:t>PARTNERZY INSTYTUCJONALNI</a:t>
+                        <a:t>Partnerzy instytucjonalni</a:t>
                       </a:r>
-                      <a:endParaRPr lang="en-US" sz="850" dirty="0"/>
+                      <a:endParaRPr lang="en-US" sz="950" dirty="0"/>
                     </a:p>
                   </a:txBody>
                   <a:tcPr marL="73152" marR="73152" marT="27432" marB="27432" anchor="ctr">
@@ -1270,14 +1198,8 @@
                       <a:headEnd type="none" w="med" len="med"/>
                       <a:tailEnd type="none" w="med" len="med"/>
                     </a:lnL>
-                    <a:lnR w="9525" cap="flat" cmpd="sng" algn="ctr">
-                      <a:solidFill>
-                        <a:srgbClr val="D5DBE2"/>
-                      </a:solidFill>
-                      <a:prstDash val="solid"/>
-                      <a:round/>
-                      <a:headEnd type="none" w="med" len="med"/>
-                      <a:tailEnd type="none" w="med" len="med"/>
+                    <a:lnR w="0" cap="flat" cmpd="sng" algn="ctr">
+                      <a:noFill/>
                     </a:lnR>
                     <a:lnT w="9525" cap="flat" cmpd="sng" algn="ctr">
                       <a:solidFill>
@@ -1302,14 +1224,96 @@
                     </a:solidFill>
                   </a:tcPr>
                 </a:tc>
-                <a:tc hMerge="1">
-                  <a:tcPr/>
-                </a:tc>
-                <a:tc hMerge="1">
-                  <a:tcPr/>
+                <a:tc>
+                  <a:txBody>
+                    <a:bodyPr/>
+                    <a:lstStyle/>
+                    <a:p>
+                      <a:pPr indent="0" marL="0">
+                        <a:buNone/>
+                      </a:pPr>
+                      <a:endParaRPr lang="en-US" sz="950" dirty="0"/>
+                    </a:p>
+                  </a:txBody>
+                  <a:tcPr marL="73152" marR="73152" marT="27432" marB="27432" anchor="ctr">
+                    <a:lnL w="0" cap="flat" cmpd="sng" algn="ctr">
+                      <a:noFill/>
+                    </a:lnL>
+                    <a:lnR w="0" cap="flat" cmpd="sng" algn="ctr">
+                      <a:noFill/>
+                    </a:lnR>
+                    <a:lnT w="9525" cap="flat" cmpd="sng" algn="ctr">
+                      <a:solidFill>
+                        <a:srgbClr val="D5DBE2"/>
+                      </a:solidFill>
+                      <a:prstDash val="solid"/>
+                      <a:round/>
+                      <a:headEnd type="none" w="med" len="med"/>
+                      <a:tailEnd type="none" w="med" len="med"/>
+                    </a:lnT>
+                    <a:lnB w="9525" cap="flat" cmpd="sng" algn="ctr">
+                      <a:solidFill>
+                        <a:srgbClr val="D5DBE2"/>
+                      </a:solidFill>
+                      <a:prstDash val="solid"/>
+                      <a:round/>
+                      <a:headEnd type="none" w="med" len="med"/>
+                      <a:tailEnd type="none" w="med" len="med"/>
+                    </a:lnB>
+                    <a:solidFill>
+                      <a:schemeClr val="bg2"/>
+                    </a:solidFill>
+                  </a:tcPr>
+                </a:tc>
+                <a:tc>
+                  <a:txBody>
+                    <a:bodyPr/>
+                    <a:lstStyle/>
+                    <a:p>
+                      <a:pPr indent="0" marL="0">
+                        <a:buNone/>
+                      </a:pPr>
+                      <a:endParaRPr lang="en-US" sz="950" dirty="0"/>
+                    </a:p>
+                  </a:txBody>
+                  <a:tcPr marL="73152" marR="73152" marT="27432" marB="27432" anchor="ctr">
+                    <a:lnL w="0" cap="flat" cmpd="sng" algn="ctr">
+                      <a:noFill/>
+                    </a:lnL>
+                    <a:lnR w="9525" cap="flat" cmpd="sng" algn="ctr">
+                      <a:solidFill>
+                        <a:srgbClr val="D5DBE2"/>
+                      </a:solidFill>
+                      <a:prstDash val="solid"/>
+                      <a:round/>
+                      <a:headEnd type="none" w="med" len="med"/>
+                      <a:tailEnd type="none" w="med" len="med"/>
+                    </a:lnR>
+                    <a:lnT w="9525" cap="flat" cmpd="sng" algn="ctr">
+                      <a:solidFill>
+                        <a:srgbClr val="D5DBE2"/>
+                      </a:solidFill>
+                      <a:prstDash val="solid"/>
+                      <a:round/>
+                      <a:headEnd type="none" w="med" len="med"/>
+                      <a:tailEnd type="none" w="med" len="med"/>
+                    </a:lnT>
+                    <a:lnB w="9525" cap="flat" cmpd="sng" algn="ctr">
+                      <a:solidFill>
+                        <a:srgbClr val="D5DBE2"/>
+                      </a:solidFill>
+                      <a:prstDash val="solid"/>
+                      <a:round/>
+                      <a:headEnd type="none" w="med" len="med"/>
+                      <a:tailEnd type="none" w="med" len="med"/>
+                    </a:lnB>
+                    <a:solidFill>
+                      <a:schemeClr val="bg2"/>
+                    </a:solidFill>
+                  </a:tcPr>
                 </a:tc>
               </a:tr>
-              <a:tr h="0">
+              <a:tr h="347472">
                 <a:tc>
                   <a:txBody>
                     <a:bodyPr/>
@@ -1382,7 +1386,7 @@
                             <a:schemeClr val="tx1"/>
                           </a:solidFill>
                         </a:rPr>
-                        <a:t>Porozumienie podpisane, korespondencja wysłana. Oczekujemy na odpowiedź i powołanie dedykowanego zespołu po stronie Ministerstwa.</a:t>
+                        <a:t>Porozumienie podpisane, korespondencja wysłana. Czekamy na odpowiedź i powołanie zespołu po stronie Ministerstwa.</a:t>
                       </a:r>
                       <a:endParaRPr lang="en-US" sz="950" dirty="0"/>
                     </a:p>
@@ -1480,7 +1484,7 @@
                   </a:tcPr>
                 </a:tc>
               </a:tr>
-              <a:tr h="0">
+              <a:tr h="347472">
                 <a:tc>
                   <a:txBody>
                     <a:bodyPr/>
@@ -1553,7 +1557,7 @@
                             <a:schemeClr val="tx1"/>
                           </a:solidFill>
                         </a:rPr>
-                        <a:t>Porozumienie podpisane, korespondencja wysłana. Oczekujemy na harmonogram działań i wskazanie zespołu projektowego po stronie partnera.</a:t>
+                        <a:t>Porozumienie podpisane, korespondencja wysłana. Czekamy na harmonogram działań i wskazanie zespołu projektowego.</a:t>
                       </a:r>
                       <a:endParaRPr lang="en-US" sz="950" dirty="0"/>
                     </a:p>
@@ -1651,7 +1655,7 @@
                   </a:tcPr>
                 </a:tc>
               </a:tr>
-              <a:tr h="0">
+              <a:tr h="347472">
                 <a:tc>
                   <a:txBody>
                     <a:bodyPr/>
@@ -1724,7 +1728,7 @@
                             <a:schemeClr val="tx1"/>
                           </a:solidFill>
                         </a:rPr>
-                        <a:t>Spotkanie 13.10 w siedzibie ARiMR w sprawie porozumienia międzyministerialnego i dalszych kroków uzyskania dostępu do bazy danych rolników.</a:t>
+                        <a:t>Spotkanie 13.10 w ARiMR: porozumienie międzyministerialne i dostęp do bazy danych rolników.</a:t>
                       </a:r>
                       <a:endParaRPr lang="en-US" sz="950" dirty="0"/>
                     </a:p>
@@ -1782,7 +1786,7 @@
                             <a:schemeClr val="accent2"/>
                           </a:solidFill>
                         </a:rPr>
-                        <a:t>Na co możemy się zgodzić we współpracy z ARiMR przy budowie Portalu Rolnika?</a:t>
+                        <a:t>Na co możemy się zgodzić przy budowie Portalu Rolnika ARiMR?</a:t>
                       </a:r>
                       <a:endParaRPr lang="en-US" sz="950" dirty="0"/>
                     </a:p>
@@ -1830,8 +1834,8 @@
                   </a:tcPr>
                 </a:tc>
               </a:tr>
-              <a:tr h="0">
-                <a:tc gridSpan="3">
+              <a:tr h="201168">
+                <a:tc>
                   <a:txBody>
                     <a:bodyPr/>
                     <a:lstStyle/>
@@ -1840,14 +1844,14 @@
                         <a:buNone/>
                       </a:pPr>
                       <a:r>
-                        <a:rPr lang="en-US" sz="850" b="1" spc="100" kern="0" dirty="0">
+                        <a:rPr lang="en-US" sz="950" b="1" spc="10" kern="0" dirty="0">
                           <a:solidFill>
                             <a:schemeClr val="accent1"/>
                           </a:solidFill>
                         </a:rPr>
-                        <a:t>PARTNERZY KOMERCYJNI</a:t>
+                        <a:t>Partnerzy komercyjni</a:t>
                       </a:r>
-                      <a:endParaRPr lang="en-US" sz="850" dirty="0"/>
+                      <a:endParaRPr lang="en-US" sz="950" dirty="0"/>
                     </a:p>
                   </a:txBody>
                   <a:tcPr marL="73152" marR="73152" marT="27432" marB="27432" anchor="ctr">
@@ -1860,14 +1864,8 @@
                       <a:headEnd type="none" w="med" len="med"/>
                       <a:tailEnd type="none" w="med" len="med"/>
                     </a:lnL>
-                    <a:lnR w="9525" cap="flat" cmpd="sng" algn="ctr">
-                      <a:solidFill>
-                        <a:srgbClr val="D5DBE2"/>
-                      </a:solidFill>
-                      <a:prstDash val="solid"/>
-                      <a:round/>
-                      <a:headEnd type="none" w="med" len="med"/>
-                      <a:tailEnd type="none" w="med" len="med"/>
+                    <a:lnR w="0" cap="flat" cmpd="sng" algn="ctr">
+                      <a:noFill/>
                     </a:lnR>
                     <a:lnT w="9525" cap="flat" cmpd="sng" algn="ctr">
                       <a:solidFill>
@@ -1892,14 +1890,96 @@
                     </a:solidFill>
                   </a:tcPr>
                 </a:tc>
-                <a:tc hMerge="1">
-                  <a:tcPr/>
-                </a:tc>
-                <a:tc hMerge="1">
-                  <a:tcPr/>
+                <a:tc>
+                  <a:txBody>
+                    <a:bodyPr/>
+                    <a:lstStyle/>
+                    <a:p>
+                      <a:pPr indent="0" marL="0">
+                        <a:buNone/>
+                      </a:pPr>
+                      <a:endParaRPr lang="en-US" sz="950" dirty="0"/>
+                    </a:p>
+                  </a:txBody>
+                  <a:tcPr marL="73152" marR="73152" marT="27432" marB="27432" anchor="ctr">
+                    <a:lnL w="0" cap="flat" cmpd="sng" algn="ctr">
+                      <a:noFill/>
+                    </a:lnL>
+                    <a:lnR w="0" cap="flat" cmpd="sng" algn="ctr">
+                      <a:noFill/>
+                    </a:lnR>
+                    <a:lnT w="9525" cap="flat" cmpd="sng" algn="ctr">
+                      <a:solidFill>
+                        <a:srgbClr val="D5DBE2"/>
+                      </a:solidFill>
+                      <a:prstDash val="solid"/>
+                      <a:round/>
+                      <a:headEnd type="none" w="med" len="med"/>
+                      <a:tailEnd type="none" w="med" len="med"/>
+                    </a:lnT>
+                    <a:lnB w="9525" cap="flat" cmpd="sng" algn="ctr">
+                      <a:solidFill>
+                        <a:srgbClr val="D5DBE2"/>
+                      </a:solidFill>
+                      <a:prstDash val="solid"/>
+                      <a:round/>
+                      <a:headEnd type="none" w="med" len="med"/>
+                      <a:tailEnd type="none" w="med" len="med"/>
+                    </a:lnB>
+                    <a:solidFill>
+                      <a:schemeClr val="bg2"/>
+                    </a:solidFill>
+                  </a:tcPr>
+                </a:tc>
+                <a:tc>
+                  <a:txBody>
+                    <a:bodyPr/>
+                    <a:lstStyle/>
+                    <a:p>
+                      <a:pPr indent="0" marL="0">
+                        <a:buNone/>
+                      </a:pPr>
+                      <a:endParaRPr lang="en-US" sz="950" dirty="0"/>
+                    </a:p>
+                  </a:txBody>
+                  <a:tcPr marL="73152" marR="73152" marT="27432" marB="27432" anchor="ctr">
+                    <a:lnL w="0" cap="flat" cmpd="sng" algn="ctr">
+                      <a:noFill/>
+                    </a:lnL>
+                    <a:lnR w="9525" cap="flat" cmpd="sng" algn="ctr">
+                      <a:solidFill>
+                        <a:srgbClr val="D5DBE2"/>
+                      </a:solidFill>
+                      <a:prstDash val="solid"/>
+                      <a:round/>
+                      <a:headEnd type="none" w="med" len="med"/>
+                      <a:tailEnd type="none" w="med" len="med"/>
+                    </a:lnR>
+                    <a:lnT w="9525" cap="flat" cmpd="sng" algn="ctr">
+                      <a:solidFill>
+                        <a:srgbClr val="D5DBE2"/>
+                      </a:solidFill>
+                      <a:prstDash val="solid"/>
+                      <a:round/>
+                      <a:headEnd type="none" w="med" len="med"/>
+                      <a:tailEnd type="none" w="med" len="med"/>
+                    </a:lnT>
+                    <a:lnB w="9525" cap="flat" cmpd="sng" algn="ctr">
+                      <a:solidFill>
+                        <a:srgbClr val="D5DBE2"/>
+                      </a:solidFill>
+                      <a:prstDash val="solid"/>
+                      <a:round/>
+                      <a:headEnd type="none" w="med" len="med"/>
+                      <a:tailEnd type="none" w="med" len="med"/>
+                    </a:lnB>
+                    <a:solidFill>
+                      <a:schemeClr val="bg2"/>
+                    </a:solidFill>
+                  </a:tcPr>
                 </a:tc>
               </a:tr>
-              <a:tr h="0">
+              <a:tr h="347472">
                 <a:tc>
                   <a:txBody>
                     <a:bodyPr/>
@@ -1972,7 +2052,7 @@
                             <a:schemeClr val="tx1"/>
                           </a:solidFill>
                         </a:rPr>
-                        <a:t>Spotkania odbyte, jest wstępne zainteresowanie udziałem w projekcie. Partner buduje dedykowany zespół.</a:t>
+                        <a:t>Spotkania odbyte, wstępne zainteresowanie udziałem w projekcie. Partner buduje dedykowany zespół.</a:t>
                       </a:r>
                       <a:endParaRPr lang="en-US" sz="950" dirty="0"/>
                     </a:p>
@@ -2030,7 +2110,7 @@
                             <a:schemeClr val="accent2"/>
                           </a:solidFill>
                         </a:rPr>
-                        <a:t>Czy zostało coś ustalone poza spotkaniami, o czym powinniśmy wiedzieć? Jaki jest aktualnie poziom zainteresowania?</a:t>
+                        <a:t>Czy coś ustalono poza spotkaniami? Jaki jest poziom zainteresowania?</a:t>
                       </a:r>
                       <a:endParaRPr lang="en-US" sz="950" dirty="0"/>
                     </a:p>
@@ -2078,7 +2158,7 @@
                   </a:tcPr>
                 </a:tc>
               </a:tr>
-              <a:tr h="0">
+              <a:tr h="347472">
                 <a:tc>
                   <a:txBody>
                     <a:bodyPr/>
@@ -2151,7 +2231,7 @@
                             <a:schemeClr val="tx1"/>
                           </a:solidFill>
                         </a:rPr>
-                        <a:t>Spotkanie z Dyrektorem ds. ubezpieczeń dla rolników. PZU przygotowuje wewnętrznie propozycję oferty ubezpieczeniowej. Najlepszym rozwiązaniem będzie moduł wewnątrz aplikacji, bez przekierowania do partnera.</a:t>
+                        <a:t>Spotkanie z Dyrektorem ds. ubezpieczeń dla rolników. PZU przygotowuje ofertę – najlepiej jako moduł w aplikacji, bez przekierowania.</a:t>
                       </a:r>
                       <a:endParaRPr lang="en-US" sz="950" dirty="0"/>
                     </a:p>
@@ -2209,7 +2289,7 @@
                             <a:schemeClr val="accent2"/>
                           </a:solidFill>
                         </a:rPr>
-                        <a:t>Czy możemy rozmawiać z PZU o rozszerzeniu wsparcia również o finansowanie i inwestycje?</a:t>
+                        <a:t>Czy rozszerzamy rozmowy z PZU o finansowanie i inwestycje?</a:t>
                       </a:r>
                       <a:endParaRPr lang="en-US" sz="950" dirty="0"/>
                     </a:p>
@@ -2257,7 +2337,7 @@
                   </a:tcPr>
                 </a:tc>
               </a:tr>
-              <a:tr h="0">
+              <a:tr h="237744">
                 <a:tc>
                   <a:txBody>
                     <a:bodyPr/>
@@ -2428,7 +2508,7 @@
                   </a:tcPr>
                 </a:tc>
               </a:tr>
-              <a:tr h="0">
+              <a:tr h="237744">
                 <a:tc>
                   <a:txBody>
                     <a:bodyPr/>
@@ -2599,8 +2679,8 @@
                   </a:tcPr>
                 </a:tc>
               </a:tr>
-              <a:tr h="0">
-                <a:tc gridSpan="3">
+              <a:tr h="201168">
+                <a:tc>
                   <a:txBody>
                     <a:bodyPr/>
                     <a:lstStyle/>
@@ -2609,14 +2689,14 @@
                         <a:buNone/>
                       </a:pPr>
                       <a:r>
-                        <a:rPr lang="en-US" sz="850" b="1" spc="100" kern="0" dirty="0">
+                        <a:rPr lang="en-US" sz="950" b="1" spc="10" kern="0" dirty="0">
                           <a:solidFill>
                             <a:schemeClr val="accent1"/>
                           </a:solidFill>
                         </a:rPr>
-                        <a:t>TECHNOLOGIA</a:t>
+                        <a:t>Technologia</a:t>
                       </a:r>
-                      <a:endParaRPr lang="en-US" sz="850" dirty="0"/>
+                      <a:endParaRPr lang="en-US" sz="950" dirty="0"/>
                     </a:p>
                   </a:txBody>
                   <a:tcPr marL="73152" marR="73152" marT="27432" marB="27432" anchor="ctr">
@@ -2629,14 +2709,8 @@
                       <a:headEnd type="none" w="med" len="med"/>
                       <a:tailEnd type="none" w="med" len="med"/>
                     </a:lnL>
-                    <a:lnR w="9525" cap="flat" cmpd="sng" algn="ctr">
-                      <a:solidFill>
-                        <a:srgbClr val="D5DBE2"/>
-                      </a:solidFill>
-                      <a:prstDash val="solid"/>
-                      <a:round/>
-                      <a:headEnd type="none" w="med" len="med"/>
-                      <a:tailEnd type="none" w="med" len="med"/>
+                    <a:lnR w="0" cap="flat" cmpd="sng" algn="ctr">
+                      <a:noFill/>
                     </a:lnR>
                     <a:lnT w="9525" cap="flat" cmpd="sng" algn="ctr">
                       <a:solidFill>
@@ -2661,14 +2735,96 @@
                     </a:solidFill>
                   </a:tcPr>
                 </a:tc>
-                <a:tc hMerge="1">
-                  <a:tcPr/>
-                </a:tc>
-                <a:tc hMerge="1">
-                  <a:tcPr/>
+                <a:tc>
+                  <a:txBody>
+                    <a:bodyPr/>
+                    <a:lstStyle/>
+                    <a:p>
+                      <a:pPr indent="0" marL="0">
+                        <a:buNone/>
+                      </a:pPr>
+                      <a:endParaRPr lang="en-US" sz="950" dirty="0"/>
+                    </a:p>
+                  </a:txBody>
+                  <a:tcPr marL="73152" marR="73152" marT="27432" marB="27432" anchor="ctr">
+                    <a:lnL w="0" cap="flat" cmpd="sng" algn="ctr">
+                      <a:noFill/>
+                    </a:lnL>
+                    <a:lnR w="0" cap="flat" cmpd="sng" algn="ctr">
+                      <a:noFill/>
+                    </a:lnR>
+                    <a:lnT w="9525" cap="flat" cmpd="sng" algn="ctr">
+                      <a:solidFill>
+                        <a:srgbClr val="D5DBE2"/>
+                      </a:solidFill>
+                      <a:prstDash val="solid"/>
+                      <a:round/>
+                      <a:headEnd type="none" w="med" len="med"/>
+                      <a:tailEnd type="none" w="med" len="med"/>
+                    </a:lnT>
+                    <a:lnB w="9525" cap="flat" cmpd="sng" algn="ctr">
+                      <a:solidFill>
+                        <a:srgbClr val="D5DBE2"/>
+                      </a:solidFill>
+                      <a:prstDash val="solid"/>
+                      <a:round/>
+                      <a:headEnd type="none" w="med" len="med"/>
+                      <a:tailEnd type="none" w="med" len="med"/>
+                    </a:lnB>
+                    <a:solidFill>
+                      <a:schemeClr val="bg2"/>
+                    </a:solidFill>
+                  </a:tcPr>
+                </a:tc>
+                <a:tc>
+                  <a:txBody>
+                    <a:bodyPr/>
+                    <a:lstStyle/>
+                    <a:p>
+                      <a:pPr indent="0" marL="0">
+                        <a:buNone/>
+                      </a:pPr>
+                      <a:endParaRPr lang="en-US" sz="950" dirty="0"/>
+                    </a:p>
+                  </a:txBody>
+                  <a:tcPr marL="73152" marR="73152" marT="27432" marB="27432" anchor="ctr">
+                    <a:lnL w="0" cap="flat" cmpd="sng" algn="ctr">
+                      <a:noFill/>
+                    </a:lnL>
+                    <a:lnR w="9525" cap="flat" cmpd="sng" algn="ctr">
+                      <a:solidFill>
+                        <a:srgbClr val="D5DBE2"/>
+                      </a:solidFill>
+                      <a:prstDash val="solid"/>
+                      <a:round/>
+                      <a:headEnd type="none" w="med" len="med"/>
+                      <a:tailEnd type="none" w="med" len="med"/>
+                    </a:lnR>
+                    <a:lnT w="9525" cap="flat" cmpd="sng" algn="ctr">
+                      <a:solidFill>
+                        <a:srgbClr val="D5DBE2"/>
+                      </a:solidFill>
+                      <a:prstDash val="solid"/>
+                      <a:round/>
+                      <a:headEnd type="none" w="med" len="med"/>
+                      <a:tailEnd type="none" w="med" len="med"/>
+                    </a:lnT>
+                    <a:lnB w="9525" cap="flat" cmpd="sng" algn="ctr">
+                      <a:solidFill>
+                        <a:srgbClr val="D5DBE2"/>
+                      </a:solidFill>
+                      <a:prstDash val="solid"/>
+                      <a:round/>
+                      <a:headEnd type="none" w="med" len="med"/>
+                      <a:tailEnd type="none" w="med" len="med"/>
+                    </a:lnB>
+                    <a:solidFill>
+                      <a:schemeClr val="bg2"/>
+                    </a:solidFill>
+                  </a:tcPr>
                 </a:tc>
               </a:tr>
-              <a:tr h="0">
+              <a:tr h="347472">
                 <a:tc>
                   <a:txBody>
                     <a:bodyPr/>
@@ -2741,7 +2897,7 @@
                             <a:schemeClr val="tx1"/>
                           </a:solidFill>
                         </a:rPr>
-                        <a:t>Razem z p. Pawłem Bizuńskim analizujemy umowę pod kątem wykorzystania funkcjonalności Farmstera w GAia. Po zgodzie działu prawnego planujemy z Działem IT pobranie kodu źródłowego z naszej chmury Azure i jego audyt.</a:t>
+                        <a:t>Z p. Pawłem Bizuńskim analizujemy umowę. Po zgodzie prawników: z IT pobranie kodu Farmstera z naszej chmury Azure i audyt.</a:t>
                       </a:r>
                       <a:endParaRPr lang="en-US" sz="950" dirty="0"/>
                     </a:p>
@@ -2847,8 +3003,8 @@
                   </a:tcPr>
                 </a:tc>
               </a:tr>
-              <a:tr h="0">
-                <a:tc gridSpan="3">
+              <a:tr h="201168">
+                <a:tc>
                   <a:txBody>
                     <a:bodyPr/>
                     <a:lstStyle/>
@@ -2857,14 +3013,14 @@
                         <a:buNone/>
                       </a:pPr>
                       <a:r>
-                        <a:rPr lang="en-US" sz="850" b="1" spc="100" kern="0" dirty="0">
+                        <a:rPr lang="en-US" sz="950" b="1" spc="10" kern="0" dirty="0">
                           <a:solidFill>
                             <a:schemeClr val="accent1"/>
                           </a:solidFill>
                         </a:rPr>
-                        <a:t>STRATEGIA</a:t>
+                        <a:t>Strategia</a:t>
                       </a:r>
-                      <a:endParaRPr lang="en-US" sz="850" dirty="0"/>
+                      <a:endParaRPr lang="en-US" sz="950" dirty="0"/>
                     </a:p>
                   </a:txBody>
                   <a:tcPr marL="73152" marR="73152" marT="27432" marB="27432" anchor="ctr">
@@ -2877,14 +3033,8 @@
                       <a:headEnd type="none" w="med" len="med"/>
                       <a:tailEnd type="none" w="med" len="med"/>
                     </a:lnL>
-                    <a:lnR w="9525" cap="flat" cmpd="sng" algn="ctr">
-                      <a:solidFill>
-                        <a:srgbClr val="D5DBE2"/>
-                      </a:solidFill>
-                      <a:prstDash val="solid"/>
-                      <a:round/>
-                      <a:headEnd type="none" w="med" len="med"/>
-                      <a:tailEnd type="none" w="med" len="med"/>
+                    <a:lnR w="0" cap="flat" cmpd="sng" algn="ctr">
+                      <a:noFill/>
                     </a:lnR>
                     <a:lnT w="9525" cap="flat" cmpd="sng" algn="ctr">
                       <a:solidFill>
@@ -2909,14 +3059,96 @@
                     </a:solidFill>
                   </a:tcPr>
                 </a:tc>
-                <a:tc hMerge="1">
-                  <a:tcPr/>
-                </a:tc>
-                <a:tc hMerge="1">
-                  <a:tcPr/>
+                <a:tc>
+                  <a:txBody>
+                    <a:bodyPr/>
+                    <a:lstStyle/>
+                    <a:p>
+                      <a:pPr indent="0" marL="0">
+                        <a:buNone/>
+                      </a:pPr>
+                      <a:endParaRPr lang="en-US" sz="950" dirty="0"/>
+                    </a:p>
+                  </a:txBody>
+                  <a:tcPr marL="73152" marR="73152" marT="27432" marB="27432" anchor="ctr">
+                    <a:lnL w="0" cap="flat" cmpd="sng" algn="ctr">
+                      <a:noFill/>
+                    </a:lnL>
+                    <a:lnR w="0" cap="flat" cmpd="sng" algn="ctr">
+                      <a:noFill/>
+                    </a:lnR>
+                    <a:lnT w="9525" cap="flat" cmpd="sng" algn="ctr">
+                      <a:solidFill>
+                        <a:srgbClr val="D5DBE2"/>
+                      </a:solidFill>
+                      <a:prstDash val="solid"/>
+                      <a:round/>
+                      <a:headEnd type="none" w="med" len="med"/>
+                      <a:tailEnd type="none" w="med" len="med"/>
+                    </a:lnT>
+                    <a:lnB w="9525" cap="flat" cmpd="sng" algn="ctr">
+                      <a:solidFill>
+                        <a:srgbClr val="D5DBE2"/>
+                      </a:solidFill>
+                      <a:prstDash val="solid"/>
+                      <a:round/>
+                      <a:headEnd type="none" w="med" len="med"/>
+                      <a:tailEnd type="none" w="med" len="med"/>
+                    </a:lnB>
+                    <a:solidFill>
+                      <a:schemeClr val="bg2"/>
+                    </a:solidFill>
+                  </a:tcPr>
+                </a:tc>
+                <a:tc>
+                  <a:txBody>
+                    <a:bodyPr/>
+                    <a:lstStyle/>
+                    <a:p>
+                      <a:pPr indent="0" marL="0">
+                        <a:buNone/>
+                      </a:pPr>
+                      <a:endParaRPr lang="en-US" sz="950" dirty="0"/>
+                    </a:p>
+                  </a:txBody>
+                  <a:tcPr marL="73152" marR="73152" marT="27432" marB="27432" anchor="ctr">
+                    <a:lnL w="0" cap="flat" cmpd="sng" algn="ctr">
+                      <a:noFill/>
+                    </a:lnL>
+                    <a:lnR w="9525" cap="flat" cmpd="sng" algn="ctr">
+                      <a:solidFill>
+                        <a:srgbClr val="D5DBE2"/>
+                      </a:solidFill>
+                      <a:prstDash val="solid"/>
+                      <a:round/>
+                      <a:headEnd type="none" w="med" len="med"/>
+                      <a:tailEnd type="none" w="med" len="med"/>
+                    </a:lnR>
+                    <a:lnT w="9525" cap="flat" cmpd="sng" algn="ctr">
+                      <a:solidFill>
+                        <a:srgbClr val="D5DBE2"/>
+                      </a:solidFill>
+                      <a:prstDash val="solid"/>
+                      <a:round/>
+                      <a:headEnd type="none" w="med" len="med"/>
+                      <a:tailEnd type="none" w="med" len="med"/>
+                    </a:lnT>
+                    <a:lnB w="9525" cap="flat" cmpd="sng" algn="ctr">
+                      <a:solidFill>
+                        <a:srgbClr val="D5DBE2"/>
+                      </a:solidFill>
+                      <a:prstDash val="solid"/>
+                      <a:round/>
+                      <a:headEnd type="none" w="med" len="med"/>
+                      <a:tailEnd type="none" w="med" len="med"/>
+                    </a:lnB>
+                    <a:solidFill>
+                      <a:schemeClr val="bg2"/>
+                    </a:solidFill>
+                  </a:tcPr>
                 </a:tc>
               </a:tr>
-              <a:tr h="0">
+              <a:tr h="347472">
                 <a:tc>
                   <a:txBody>
                     <a:bodyPr/>
@@ -2989,7 +3221,7 @@
                             <a:schemeClr val="tx1"/>
                           </a:solidFill>
                         </a:rPr>
-                        <a:t>GAia została włączona do strategii nawozowej. Obszar będzie omawiany z Wiceprezesem Piotrem Szajczykiem.</a:t>
+                        <a:t>GAia włączona do strategii nawozowej. Obszar będzie omawiany z Wiceprezesem Piotrem Szajczykiem.</a:t>
                       </a:r>
                       <a:endParaRPr lang="en-US" sz="950" dirty="0"/>
                     </a:p>
@@ -3047,7 +3279,7 @@
                             <a:schemeClr val="accent2"/>
                           </a:solidFill>
                         </a:rPr>
-                        <a:t>Czy dołączamy GAię do innych strategii budowanych aktualnie w Grupie?</a:t>
+                        <a:t>Czy dołączamy GAię do innych strategii budowanych w Grupie?</a:t>
                       </a:r>
                       <a:endParaRPr lang="en-US" sz="950" dirty="0"/>
                     </a:p>

</xml_diff>